<commit_message>
slides: add codefest presentation slide (1-min, single slide)
</commit_message>
<xml_diff>
--- a/codefest/codefest_presentation_bao_nguyen.pptx
+++ b/codefest/codefest_presentation_bao_nguyen.pptx
@@ -3084,7 +3084,7 @@
     <p:bg>
       <p:bgPr>
         <a:solidFill>
-          <a:srgbClr val="0F1428"/>
+          <a:srgbClr val="1A1A2E"/>
         </a:solidFill>
         <a:effectLst/>
       </p:bgPr>
@@ -3105,13 +3105,13 @@
         <p:spPr>
           <a:xfrm>
             <a:off x="0" y="0"/>
-            <a:ext cx="12188952" cy="1051560"/>
+            <a:ext cx="12188952" cy="640080"/>
           </a:xfrm>
           <a:prstGeom prst="rect">
             <a:avLst/>
           </a:prstGeom>
           <a:solidFill>
-            <a:srgbClr val="1E3264"/>
+            <a:srgbClr val="16213E"/>
           </a:solidFill>
           <a:ln>
             <a:noFill/>
@@ -3147,8 +3147,8 @@
         </p:nvSpPr>
         <p:spPr>
           <a:xfrm>
-            <a:off x="228600" y="73152"/>
-            <a:ext cx="8229600" cy="502920"/>
+            <a:off x="137160" y="45720"/>
+            <a:ext cx="8229600" cy="548640"/>
           </a:xfrm>
           <a:prstGeom prst="rect">
             <a:avLst/>
@@ -3163,12 +3163,12 @@
           <a:p>
             <a:pPr algn="l"/>
             <a:r>
-              <a:rPr sz="2200" b="1">
+              <a:rPr sz="2000" b="1">
                 <a:solidFill>
                   <a:srgbClr val="FFFFFF"/>
                 </a:solidFill>
               </a:rPr>
-              <a:t>K-Means Image Color Quantization — Hardware Accelerator</a:t>
+              <a:t>K-Means Image Color Quantization Accelerator</a:t>
             </a:r>
           </a:p>
         </p:txBody>
@@ -3181,8 +3181,8 @@
         </p:nvSpPr>
         <p:spPr>
           <a:xfrm>
-            <a:off x="228600" y="594360"/>
-            <a:ext cx="8229600" cy="365760"/>
+            <a:off x="8686800" y="45720"/>
+            <a:ext cx="3383280" cy="548640"/>
           </a:xfrm>
           <a:prstGeom prst="rect">
             <a:avLst/>
@@ -3195,14 +3195,14 @@
           </a:bodyPr>
           <a:lstStyle/>
           <a:p>
-            <a:pPr algn="l"/>
-            <a:r>
-              <a:rPr sz="1100" b="0">
-                <a:solidFill>
-                  <a:srgbClr val="B4C8FF"/>
+            <a:pPr algn="r"/>
+            <a:r>
+              <a:rPr sz="1000" b="0">
+                <a:solidFill>
+                  <a:srgbClr val="AABBCC"/>
                 </a:solidFill>
               </a:rPr>
-              <a:t>Bao Nguyen  |  ECE 410/510 Spring 2026  |  Codefest Presentation</a:t>
+              <a:t>Bao Nguyen  |  ECE 410/510  |  Spring 2026</a:t>
             </a:r>
           </a:p>
         </p:txBody>
@@ -3215,14 +3215,14 @@
         </p:nvSpPr>
         <p:spPr>
           <a:xfrm>
-            <a:off x="10515600" y="182880"/>
-            <a:ext cx="1463040" cy="548640"/>
+            <a:off x="137160" y="713232"/>
+            <a:ext cx="1417320" cy="868680"/>
           </a:xfrm>
           <a:prstGeom prst="rect">
             <a:avLst/>
           </a:prstGeom>
           <a:solidFill>
-            <a:srgbClr val="641414"/>
+            <a:srgbClr val="E83E3E"/>
           </a:solidFill>
           <a:ln>
             <a:noFill/>
@@ -3258,8 +3258,8 @@
         </p:nvSpPr>
         <p:spPr>
           <a:xfrm>
-            <a:off x="10533888" y="201168"/>
-            <a:ext cx="1426464" cy="502920"/>
+            <a:off x="137160" y="713232"/>
+            <a:ext cx="1417320" cy="502920"/>
           </a:xfrm>
           <a:prstGeom prst="rect">
             <a:avLst/>
@@ -3274,33 +3274,315 @@
           <a:p>
             <a:pPr algn="ctr"/>
             <a:r>
-              <a:rPr sz="900" b="1">
+              <a:rPr sz="3400" b="1">
                 <a:solidFill>
                   <a:srgbClr val="FFFFFF"/>
                 </a:solidFill>
               </a:rPr>
-              <a:t>Portland State
-University</a:t>
-            </a:r>
-          </a:p>
-        </p:txBody>
-      </p:sp>
-      <p:sp>
-        <p:nvSpPr>
-          <p:cNvPr id="7" name="Rectangle 6"/>
+              <a:t>62×</a:t>
+            </a:r>
+          </a:p>
+        </p:txBody>
+      </p:sp>
+      <p:sp>
+        <p:nvSpPr>
+          <p:cNvPr id="7" name="TextBox 6"/>
+          <p:cNvSpPr txBox="1"/>
+          <p:nvPr/>
+        </p:nvSpPr>
+        <p:spPr>
+          <a:xfrm>
+            <a:off x="137160" y="1170432"/>
+            <a:ext cx="1417320" cy="384048"/>
+          </a:xfrm>
+          <a:prstGeom prst="rect">
+            <a:avLst/>
+          </a:prstGeom>
+          <a:noFill/>
+        </p:spPr>
+        <p:txBody>
+          <a:bodyPr wrap="square">
+            <a:spAutoFit/>
+          </a:bodyPr>
+          <a:lstStyle/>
+          <a:p>
+            <a:pPr algn="ctr"/>
+            <a:r>
+              <a:rPr sz="800" b="0">
+                <a:solidFill>
+                  <a:srgbClr val="FFFFFF"/>
+                </a:solidFill>
+              </a:rPr>
+              <a:t>projected
+speedup</a:t>
+            </a:r>
+          </a:p>
+        </p:txBody>
+      </p:sp>
+      <p:sp>
+        <p:nvSpPr>
+          <p:cNvPr id="8" name="TextBox 7"/>
+          <p:cNvSpPr txBox="1"/>
+          <p:nvPr/>
+        </p:nvSpPr>
+        <p:spPr>
+          <a:xfrm>
+            <a:off x="1664208" y="685800"/>
+            <a:ext cx="4069080" cy="5943600"/>
+          </a:xfrm>
+          <a:prstGeom prst="rect">
+            <a:avLst/>
+          </a:prstGeom>
+          <a:noFill/>
+        </p:spPr>
+        <p:txBody>
+          <a:bodyPr wrap="square">
+            <a:spAutoFit/>
+          </a:bodyPr>
+          <a:lstStyle/>
+          <a:p>
+            <a:pPr>
+              <a:spcAft>
+                <a:spcPts val="200"/>
+              </a:spcAft>
+            </a:pPr>
+            <a:r>
+              <a:rPr sz="950" b="1">
+                <a:solidFill>
+                  <a:srgbClr val="FFFFFF"/>
+                </a:solidFill>
+              </a:rPr>
+              <a:t>What am I doing?</a:t>
+            </a:r>
+          </a:p>
+          <a:p>
+            <a:pPr lvl="1">
+              <a:spcAft>
+                <a:spcPts val="200"/>
+              </a:spcAft>
+            </a:pPr>
+            <a:r>
+              <a:rPr sz="900" b="0">
+                <a:solidFill>
+                  <a:srgbClr val="D2D2D2"/>
+                </a:solidFill>
+              </a:rPr>
+              <a:t>• Custom chip: reduces any photo to 16 colors by grouping similar pixels</a:t>
+            </a:r>
+          </a:p>
+          <a:p>
+            <a:pPr>
+              <a:spcAft>
+                <a:spcPts val="200"/>
+              </a:spcAft>
+            </a:pPr>
+            <a:r>
+              <a:rPr sz="950" b="1">
+                <a:solidFill>
+                  <a:srgbClr val="FFFFFF"/>
+                </a:solidFill>
+              </a:rPr>
+              <a:t>How is it done today?</a:t>
+            </a:r>
+          </a:p>
+          <a:p>
+            <a:pPr lvl="1">
+              <a:spcAft>
+                <a:spcPts val="200"/>
+              </a:spcAft>
+            </a:pPr>
+            <a:r>
+              <a:rPr sz="900" b="0">
+                <a:solidFill>
+                  <a:srgbClr val="D2D2D2"/>
+                </a:solidFill>
+              </a:rPr>
+              <a:t>• Runs on CPU — ~9 sec/image, using &lt;1% of CPU computing power</a:t>
+            </a:r>
+          </a:p>
+          <a:p>
+            <a:pPr lvl="1">
+              <a:spcAft>
+                <a:spcPts val="200"/>
+              </a:spcAft>
+            </a:pPr>
+            <a:r>
+              <a:rPr sz="900" b="0">
+                <a:solidFill>
+                  <a:srgbClr val="D2D2D2"/>
+                </a:solidFill>
+              </a:rPr>
+              <a:t>• Bottleneck is memory: CPU waits for data, not doing math (46% of runtime)</a:t>
+            </a:r>
+          </a:p>
+          <a:p>
+            <a:pPr>
+              <a:spcAft>
+                <a:spcPts val="200"/>
+              </a:spcAft>
+            </a:pPr>
+            <a:r>
+              <a:rPr sz="950" b="1">
+                <a:solidFill>
+                  <a:srgbClr val="FFFFFF"/>
+                </a:solidFill>
+              </a:rPr>
+              <a:t>What am I doing differently?</a:t>
+            </a:r>
+          </a:p>
+          <a:p>
+            <a:pPr lvl="1">
+              <a:spcAft>
+                <a:spcPts val="200"/>
+              </a:spcAft>
+            </a:pPr>
+            <a:r>
+              <a:rPr sz="900" b="0">
+                <a:solidFill>
+                  <a:srgbClr val="D2D2D2"/>
+                </a:solidFill>
+              </a:rPr>
+              <a:t>• Memory &amp; math units side-by-side — no waiting (near-memory PIM chiplet)</a:t>
+            </a:r>
+          </a:p>
+          <a:p>
+            <a:pPr lvl="1">
+              <a:spcAft>
+                <a:spcPts val="200"/>
+              </a:spcAft>
+            </a:pPr>
+            <a:r>
+              <a:rPr sz="900" b="0">
+                <a:solidFill>
+                  <a:srgbClr val="D2D2D2"/>
+                </a:solidFill>
+              </a:rPr>
+              <a:t>• 16 TB/s internal bandwidth vs CPU — ~62× speedup</a:t>
+            </a:r>
+          </a:p>
+          <a:p>
+            <a:pPr>
+              <a:spcAft>
+                <a:spcPts val="200"/>
+              </a:spcAft>
+            </a:pPr>
+            <a:r>
+              <a:rPr sz="950" b="1">
+                <a:solidFill>
+                  <a:srgbClr val="FFFFFF"/>
+                </a:solidFill>
+              </a:rPr>
+              <a:t>Accomplished so far</a:t>
+            </a:r>
+          </a:p>
+          <a:p>
+            <a:pPr lvl="1">
+              <a:spcAft>
+                <a:spcPts val="200"/>
+              </a:spcAft>
+            </a:pPr>
+            <a:r>
+              <a:rPr sz="900" b="0">
+                <a:solidFill>
+                  <a:srgbClr val="D2D2D2"/>
+                </a:solidFill>
+              </a:rPr>
+              <a:t>• Benchmarked CPU baseline, confirmed memory bottleneck</a:t>
+            </a:r>
+          </a:p>
+          <a:p>
+            <a:pPr lvl="1">
+              <a:spcAft>
+                <a:spcPts val="200"/>
+              </a:spcAft>
+            </a:pPr>
+            <a:r>
+              <a:rPr sz="900" b="0">
+                <a:solidFill>
+                  <a:srgbClr val="D2D2D2"/>
+                </a:solidFill>
+              </a:rPr>
+              <a:t>• Wrote &amp; simulated all hardware — distance engine, AXI4-Lite interface,</a:t>
+            </a:r>
+          </a:p>
+          <a:p>
+            <a:pPr lvl="1">
+              <a:spcAft>
+                <a:spcPts val="200"/>
+              </a:spcAft>
+            </a:pPr>
+            <a:r>
+              <a:rPr sz="900" b="0">
+                <a:solidFill>
+                  <a:srgbClr val="D2D2D2"/>
+                </a:solidFill>
+              </a:rPr>
+              <a:t>•   compute core — all passing testbenches</a:t>
+            </a:r>
+          </a:p>
+          <a:p>
+            <a:pPr>
+              <a:spcAft>
+                <a:spcPts val="200"/>
+              </a:spcAft>
+            </a:pPr>
+            <a:r>
+              <a:rPr sz="950" b="1">
+                <a:solidFill>
+                  <a:srgbClr val="FFFFFF"/>
+                </a:solidFill>
+              </a:rPr>
+              <a:t>What's next?</a:t>
+            </a:r>
+          </a:p>
+          <a:p>
+            <a:pPr lvl="1">
+              <a:spcAft>
+                <a:spcPts val="200"/>
+              </a:spcAft>
+            </a:pPr>
+            <a:r>
+              <a:rPr sz="900" b="0">
+                <a:solidFill>
+                  <a:srgbClr val="D2D2D2"/>
+                </a:solidFill>
+              </a:rPr>
+              <a:t>• Connect pieces into full system, verify timing,</a:t>
+            </a:r>
+          </a:p>
+          <a:p>
+            <a:pPr lvl="1">
+              <a:spcAft>
+                <a:spcPts val="200"/>
+              </a:spcAft>
+            </a:pPr>
+            <a:r>
+              <a:rPr sz="900" b="0">
+                <a:solidFill>
+                  <a:srgbClr val="D2D2D2"/>
+                </a:solidFill>
+              </a:rPr>
+              <a:t>•   compare throughput vs 9-sec baseline → declare success</a:t>
+            </a:r>
+          </a:p>
+        </p:txBody>
+      </p:sp>
+      <p:sp>
+        <p:nvSpPr>
+          <p:cNvPr id="9" name="Rectangle 8"/>
           <p:cNvSpPr/>
           <p:nvPr/>
         </p:nvSpPr>
         <p:spPr>
           <a:xfrm>
-            <a:off x="137160" y="1143000"/>
-            <a:ext cx="3794760" cy="2331720"/>
+            <a:off x="5897880" y="685800"/>
+            <a:ext cx="6144768" cy="228600"/>
           </a:xfrm>
           <a:prstGeom prst="rect">
             <a:avLst/>
           </a:prstGeom>
           <a:solidFill>
-            <a:srgbClr val="192D5A"/>
+            <a:srgbClr val="0F3D5C"/>
           </a:solidFill>
           <a:ln>
             <a:noFill/>
@@ -3330,14 +3612,14 @@
       </p:sp>
       <p:sp>
         <p:nvSpPr>
-          <p:cNvPr id="8" name="TextBox 7"/>
+          <p:cNvPr id="10" name="TextBox 9"/>
           <p:cNvSpPr txBox="1"/>
           <p:nvPr/>
         </p:nvSpPr>
         <p:spPr>
           <a:xfrm>
-            <a:off x="228600" y="1280160"/>
-            <a:ext cx="3566160" cy="320040"/>
+            <a:off x="5943600" y="704088"/>
+            <a:ext cx="6053328" cy="201168"/>
           </a:xfrm>
           <a:prstGeom prst="rect">
             <a:avLst/>
@@ -3352,67 +3634,56 @@
           <a:p>
             <a:pPr algn="l"/>
             <a:r>
-              <a:rPr sz="900" b="1">
-                <a:solidFill>
-                  <a:srgbClr val="3C82DC"/>
+              <a:rPr sz="800" b="1">
+                <a:solidFill>
+                  <a:srgbClr val="4FC3F7"/>
                 </a:solidFill>
               </a:rPr>
-              <a:t>A  WHAT WE'RE DOING</a:t>
-            </a:r>
-          </a:p>
-        </p:txBody>
-      </p:sp>
-      <p:sp>
-        <p:nvSpPr>
-          <p:cNvPr id="9" name="TextBox 8"/>
-          <p:cNvSpPr txBox="1"/>
+              <a:t>Roofline: CPU vs PIM Accelerator</a:t>
+            </a:r>
+          </a:p>
+        </p:txBody>
+      </p:sp>
+      <p:pic>
+        <p:nvPicPr>
+          <p:cNvPr id="11" name="Picture 10" descr="roofline_project.png"/>
+          <p:cNvPicPr>
+            <a:picLocks noChangeAspect="1"/>
+          </p:cNvPicPr>
           <p:nvPr/>
-        </p:nvSpPr>
+        </p:nvPicPr>
+        <p:blipFill>
+          <a:blip r:embed="rId2"/>
+          <a:stretch>
+            <a:fillRect/>
+          </a:stretch>
+        </p:blipFill>
         <p:spPr>
           <a:xfrm>
-            <a:off x="228600" y="1527048"/>
-            <a:ext cx="3566160" cy="1828800"/>
+            <a:off x="5897880" y="932688"/>
+            <a:ext cx="6144768" cy="2331720"/>
           </a:xfrm>
           <a:prstGeom prst="rect">
             <a:avLst/>
           </a:prstGeom>
-          <a:noFill/>
         </p:spPr>
-        <p:txBody>
-          <a:bodyPr wrap="square">
-            <a:spAutoFit/>
-          </a:bodyPr>
-          <a:lstStyle/>
-          <a:p>
-            <a:pPr algn="l"/>
-            <a:r>
-              <a:rPr sz="1050" b="0">
-                <a:solidFill>
-                  <a:srgbClr val="DCE6FF"/>
-                </a:solidFill>
-              </a:rPr>
-              <a:t>K-Means image color quantization: reduce any image to K=16 distinct colors by clustering pixels in RGB space.
-Goal: offload the bottleneck kernel to a custom near-memory PIM accelerator to achieve a &gt;60× speedup over CPU.</a:t>
-            </a:r>
-          </a:p>
-        </p:txBody>
-      </p:sp>
-      <p:sp>
-        <p:nvSpPr>
-          <p:cNvPr id="10" name="Rectangle 9"/>
+      </p:pic>
+      <p:sp>
+        <p:nvSpPr>
+          <p:cNvPr id="12" name="Rectangle 11"/>
           <p:cNvSpPr/>
           <p:nvPr/>
         </p:nvSpPr>
         <p:spPr>
           <a:xfrm>
-            <a:off x="4041648" y="1143000"/>
-            <a:ext cx="3931920" cy="2331720"/>
+            <a:off x="5897880" y="3145536"/>
+            <a:ext cx="3026664" cy="228600"/>
           </a:xfrm>
           <a:prstGeom prst="rect">
             <a:avLst/>
           </a:prstGeom>
           <a:solidFill>
-            <a:srgbClr val="14264B"/>
+            <a:srgbClr val="0F3D5C"/>
           </a:solidFill>
           <a:ln>
             <a:noFill/>
@@ -3442,14 +3713,14 @@
       </p:sp>
       <p:sp>
         <p:nvSpPr>
-          <p:cNvPr id="11" name="TextBox 10"/>
+          <p:cNvPr id="13" name="TextBox 12"/>
           <p:cNvSpPr txBox="1"/>
           <p:nvPr/>
         </p:nvSpPr>
         <p:spPr>
           <a:xfrm>
-            <a:off x="4133087" y="1280160"/>
-            <a:ext cx="3749039" cy="320040"/>
+            <a:off x="5943600" y="3163824"/>
+            <a:ext cx="2935224" cy="201168"/>
           </a:xfrm>
           <a:prstGeom prst="rect">
             <a:avLst/>
@@ -3464,71 +3735,32 @@
           <a:p>
             <a:pPr algn="l"/>
             <a:r>
-              <a:rPr sz="900" b="1">
-                <a:solidFill>
-                  <a:srgbClr val="DC961E"/>
+              <a:rPr sz="800" b="1">
+                <a:solidFill>
+                  <a:srgbClr val="4FC3F7"/>
                 </a:solidFill>
               </a:rPr>
-              <a:t>B  HOW OTHERS DO IT</a:t>
-            </a:r>
-          </a:p>
-        </p:txBody>
-      </p:sp>
-      <p:sp>
-        <p:nvSpPr>
-          <p:cNvPr id="12" name="TextBox 11"/>
-          <p:cNvSpPr txBox="1"/>
+              <a:t>Before (original)</a:t>
+            </a:r>
+          </a:p>
+        </p:txBody>
+      </p:sp>
+      <p:sp>
+        <p:nvSpPr>
+          <p:cNvPr id="14" name="Rectangle 13"/>
+          <p:cNvSpPr/>
           <p:nvPr/>
         </p:nvSpPr>
         <p:spPr>
           <a:xfrm>
-            <a:off x="4133087" y="1527048"/>
-            <a:ext cx="3749039" cy="1828800"/>
-          </a:xfrm>
-          <a:prstGeom prst="rect">
-            <a:avLst/>
-          </a:prstGeom>
-          <a:noFill/>
-        </p:spPr>
-        <p:txBody>
-          <a:bodyPr wrap="square">
-            <a:spAutoFit/>
-          </a:bodyPr>
-          <a:lstStyle/>
-          <a:p>
-            <a:pPr algn="l"/>
-            <a:r>
-              <a:rPr sz="1000" b="0">
-                <a:solidFill>
-                  <a:srgbClr val="DCE6FF"/>
-                </a:solidFill>
-              </a:rPr>
-              <a:t>CPU (NumPy) baseline on Intel i9-12900H:
-  • Median runtime: 8.85 s / image (800×600, K=16)
-  • Pairwise distance kernel = 46% of total runtime
-  • Arithmetic Intensity = 1.68 FLOP/byte (memory-bound)
-  • Attainable ceiling ≈ 129 GFLOP/s (&lt; 10% of peak compute)
-GPU / FPGA variants exist but still feed data over PCIe — the off-chip memory wall remains the bottleneck.</a:t>
-            </a:r>
-          </a:p>
-        </p:txBody>
-      </p:sp>
-      <p:sp>
-        <p:nvSpPr>
-          <p:cNvPr id="13" name="Rectangle 12"/>
-          <p:cNvSpPr/>
-          <p:nvPr/>
-        </p:nvSpPr>
-        <p:spPr>
-          <a:xfrm>
-            <a:off x="8083296" y="1143000"/>
-            <a:ext cx="3931920" cy="2331720"/>
+            <a:off x="5897880" y="3401568"/>
+            <a:ext cx="3026664" cy="2103120"/>
           </a:xfrm>
           <a:prstGeom prst="rect">
             <a:avLst/>
           </a:prstGeom>
           <a:solidFill>
-            <a:srgbClr val="144B32"/>
+            <a:srgbClr val="2A2A3E"/>
           </a:solidFill>
           <a:ln>
             <a:noFill/>
@@ -3558,14 +3790,14 @@
       </p:sp>
       <p:sp>
         <p:nvSpPr>
-          <p:cNvPr id="14" name="TextBox 13"/>
+          <p:cNvPr id="15" name="TextBox 14"/>
           <p:cNvSpPr txBox="1"/>
           <p:nvPr/>
         </p:nvSpPr>
         <p:spPr>
           <a:xfrm>
-            <a:off x="8174736" y="1280160"/>
-            <a:ext cx="3749039" cy="320040"/>
+            <a:off x="6080760" y="4270248"/>
+            <a:ext cx="2660904" cy="365760"/>
           </a:xfrm>
           <a:prstGeom prst="rect">
             <a:avLst/>
@@ -3578,55 +3810,14 @@
           </a:bodyPr>
           <a:lstStyle/>
           <a:p>
-            <a:pPr algn="l"/>
-            <a:r>
-              <a:rPr sz="900" b="1">
-                <a:solidFill>
-                  <a:srgbClr val="28AA64"/>
+            <a:pPr algn="ctr"/>
+            <a:r>
+              <a:rPr sz="800" b="0">
+                <a:solidFill>
+                  <a:srgbClr val="8888AA"/>
                 </a:solidFill>
               </a:rPr>
-              <a:t>C  WHAT WE DO DIFFERENTLY</a:t>
-            </a:r>
-          </a:p>
-        </p:txBody>
-      </p:sp>
-      <p:sp>
-        <p:nvSpPr>
-          <p:cNvPr id="15" name="TextBox 14"/>
-          <p:cNvSpPr txBox="1"/>
-          <p:nvPr/>
-        </p:nvSpPr>
-        <p:spPr>
-          <a:xfrm>
-            <a:off x="8174736" y="1527048"/>
-            <a:ext cx="3749039" cy="1828800"/>
-          </a:xfrm>
-          <a:prstGeom prst="rect">
-            <a:avLst/>
-          </a:prstGeom>
-          <a:noFill/>
-        </p:spPr>
-        <p:txBody>
-          <a:bodyPr wrap="square">
-            <a:spAutoFit/>
-          </a:bodyPr>
-          <a:lstStyle/>
-          <a:p>
-            <a:pPr algn="l"/>
-            <a:r>
-              <a:rPr sz="1000" b="0">
-                <a:solidFill>
-                  <a:srgbClr val="DCE6FF"/>
-                </a:solidFill>
-              </a:rPr>
-              <a:t>HW/SW partition:
-  • CPU handles I/O, init, convergence, centroid updates
-  • Distance kernel → PIM chiplet (HBM3)
-    – 16 TB/s on-chip bandwidth
-    – 8 TFLOP/s FP32 compute
-    – UCIe interface (51× headroom over required 50 GB/s)
-Ridge point drops from 18.23 → 0.5 FLOP/byte,
-making kernel compute-bound → ~62× speedup.</a:t>
+              <a:t>← add bliss_original.jpg</a:t>
             </a:r>
           </a:p>
         </p:txBody>
@@ -3639,14 +3830,14 @@
         </p:nvSpPr>
         <p:spPr>
           <a:xfrm>
-            <a:off x="137160" y="3611880"/>
-            <a:ext cx="3794760" cy="2834640"/>
+            <a:off x="9015984" y="3145536"/>
+            <a:ext cx="3026664" cy="228600"/>
           </a:xfrm>
           <a:prstGeom prst="rect">
             <a:avLst/>
           </a:prstGeom>
           <a:solidFill>
-            <a:srgbClr val="121E41"/>
+            <a:srgbClr val="0F3D5C"/>
           </a:solidFill>
           <a:ln>
             <a:noFill/>
@@ -3682,8 +3873,8 @@
         </p:nvSpPr>
         <p:spPr>
           <a:xfrm>
-            <a:off x="228600" y="3749040"/>
-            <a:ext cx="3566160" cy="320040"/>
+            <a:off x="9061704" y="3163824"/>
+            <a:ext cx="2935224" cy="201168"/>
           </a:xfrm>
           <a:prstGeom prst="rect">
             <a:avLst/>
@@ -3698,60 +3889,40 @@
           <a:p>
             <a:pPr algn="l"/>
             <a:r>
-              <a:rPr sz="900" b="1">
-                <a:solidFill>
-                  <a:srgbClr val="3C82DC"/>
+              <a:rPr sz="800" b="1">
+                <a:solidFill>
+                  <a:srgbClr val="4FC3F7"/>
                 </a:solidFill>
               </a:rPr>
-              <a:t>ROOFLINE ANALYSIS</a:t>
-            </a:r>
-          </a:p>
-        </p:txBody>
-      </p:sp>
-      <p:sp>
-        <p:nvSpPr>
-          <p:cNvPr id="18" name="TextBox 17"/>
-          <p:cNvSpPr txBox="1"/>
+              <a:t>After (16 colors, K-Means)</a:t>
+            </a:r>
+          </a:p>
+        </p:txBody>
+      </p:sp>
+      <p:pic>
+        <p:nvPicPr>
+          <p:cNvPr id="18" name="Picture 17" descr="bliss_quantized.png"/>
+          <p:cNvPicPr>
+            <a:picLocks noChangeAspect="1"/>
+          </p:cNvPicPr>
           <p:nvPr/>
-        </p:nvSpPr>
+        </p:nvPicPr>
+        <p:blipFill>
+          <a:blip r:embed="rId3"/>
+          <a:stretch>
+            <a:fillRect/>
+          </a:stretch>
+        </p:blipFill>
         <p:spPr>
           <a:xfrm>
-            <a:off x="182880" y="4023360"/>
-            <a:ext cx="3657600" cy="2331720"/>
+            <a:off x="9015984" y="3401568"/>
+            <a:ext cx="3026664" cy="2103120"/>
           </a:xfrm>
           <a:prstGeom prst="rect">
             <a:avLst/>
           </a:prstGeom>
-          <a:noFill/>
         </p:spPr>
-        <p:txBody>
-          <a:bodyPr wrap="square">
-            <a:spAutoFit/>
-          </a:bodyPr>
-          <a:lstStyle/>
-          <a:p>
-            <a:pPr algn="l"/>
-            <a:r>
-              <a:rPr sz="850" b="0">
-                <a:solidFill>
-                  <a:srgbClr val="B4D2FF"/>
-                </a:solidFill>
-              </a:rPr>
-              <a:t>GFLOP/s
-10,000 ┤━━━━━━━━━━━━━━━━━━━━ CPU PEAK
-       │            ╱
-  8,000┤ PIM PEAK══╪━━━━━━━━━━━━━━━━
-       │       ╱   ●  K-Means on PIM
-       │     ╱         (compute-bound!)
-   129 ┤━━━╪━━━━━━ CPU ceiling
-       │   ● K-Means CPU (mem-bound)
-       └───┴──────────────────────
-        0.5  1.68     31.25  170
-              Arithmetic Intensity (FLOP/byte)</a:t>
-            </a:r>
-          </a:p>
-        </p:txBody>
-      </p:sp>
+      </p:pic>
       <p:sp>
         <p:nvSpPr>
           <p:cNvPr id="19" name="Rectangle 18"/>
@@ -3760,14 +3931,14 @@
         </p:nvSpPr>
         <p:spPr>
           <a:xfrm>
-            <a:off x="4041648" y="3611880"/>
-            <a:ext cx="3931920" cy="2834640"/>
+            <a:off x="5897880" y="5577840"/>
+            <a:ext cx="6144768" cy="228600"/>
           </a:xfrm>
           <a:prstGeom prst="rect">
             <a:avLst/>
           </a:prstGeom>
           <a:solidFill>
-            <a:srgbClr val="1E3C28"/>
+            <a:srgbClr val="0F3D5C"/>
           </a:solidFill>
           <a:ln>
             <a:noFill/>
@@ -3803,8 +3974,8 @@
         </p:nvSpPr>
         <p:spPr>
           <a:xfrm>
-            <a:off x="4133087" y="3749040"/>
-            <a:ext cx="3749039" cy="320040"/>
+            <a:off x="5943600" y="5596127"/>
+            <a:ext cx="6053328" cy="201168"/>
           </a:xfrm>
           <a:prstGeom prst="rect">
             <a:avLst/>
@@ -3819,253 +3990,40 @@
           <a:p>
             <a:pPr algn="l"/>
             <a:r>
-              <a:rPr sz="900" b="1">
-                <a:solidFill>
-                  <a:srgbClr val="28AA64"/>
+              <a:rPr sz="800" b="1">
+                <a:solidFill>
+                  <a:srgbClr val="4FC3F7"/>
                 </a:solidFill>
               </a:rPr>
-              <a:t>D  ACCOMPLISHED SO FAR</a:t>
-            </a:r>
-          </a:p>
-        </p:txBody>
-      </p:sp>
-      <p:sp>
-        <p:nvSpPr>
-          <p:cNvPr id="21" name="TextBox 20"/>
-          <p:cNvSpPr txBox="1"/>
+              <a:t>System Architecture</a:t>
+            </a:r>
+          </a:p>
+        </p:txBody>
+      </p:sp>
+      <p:pic>
+        <p:nvPicPr>
+          <p:cNvPr id="21" name="Picture 20" descr="system_diagram.png"/>
+          <p:cNvPicPr>
+            <a:picLocks noChangeAspect="1"/>
+          </p:cNvPicPr>
           <p:nvPr/>
-        </p:nvSpPr>
+        </p:nvPicPr>
+        <p:blipFill>
+          <a:blip r:embed="rId4"/>
+          <a:stretch>
+            <a:fillRect/>
+          </a:stretch>
+        </p:blipFill>
         <p:spPr>
           <a:xfrm>
-            <a:off x="4133087" y="3995928"/>
-            <a:ext cx="3749039" cy="2331720"/>
+            <a:off x="5897880" y="5824728"/>
+            <a:ext cx="6144768" cy="914400"/>
           </a:xfrm>
           <a:prstGeom prst="rect">
             <a:avLst/>
           </a:prstGeom>
-          <a:noFill/>
         </p:spPr>
-        <p:txBody>
-          <a:bodyPr wrap="square">
-            <a:spAutoFit/>
-          </a:bodyPr>
-          <a:lstStyle/>
-          <a:p>
-            <a:pPr algn="l"/>
-            <a:r>
-              <a:rPr sz="1050" b="0">
-                <a:solidFill>
-                  <a:srgbClr val="DCE6FF"/>
-                </a:solidFill>
-              </a:rPr>
-              <a:t>✔  Software baseline benchmarked (8.85 s median)
-✔  cProfile: distance kernel = 46% of runtime
-✔  Roofline model built — AI = 1.68 FLOP/byte
-✔  CPU bottleneck confirmed as memory bandwidth
-✔  HW/SW partition designed
-✔  Interface selected: UCIe (2.56 TB/s, 51× headroom)
-✔  Block diagram &amp; system architecture documented
-✔  Theoretical speedup quantified: ~62×</a:t>
-            </a:r>
-          </a:p>
-        </p:txBody>
-      </p:sp>
-      <p:sp>
-        <p:nvSpPr>
-          <p:cNvPr id="22" name="Rectangle 21"/>
-          <p:cNvSpPr/>
-          <p:nvPr/>
-        </p:nvSpPr>
-        <p:spPr>
-          <a:xfrm>
-            <a:off x="8083296" y="3611880"/>
-            <a:ext cx="3931920" cy="2834640"/>
-          </a:xfrm>
-          <a:prstGeom prst="rect">
-            <a:avLst/>
-          </a:prstGeom>
-          <a:solidFill>
-            <a:srgbClr val="411E1E"/>
-          </a:solidFill>
-          <a:ln>
-            <a:noFill/>
-          </a:ln>
-        </p:spPr>
-        <p:style>
-          <a:lnRef idx="1">
-            <a:schemeClr val="accent1"/>
-          </a:lnRef>
-          <a:fillRef idx="3">
-            <a:schemeClr val="accent1"/>
-          </a:fillRef>
-          <a:effectRef idx="2">
-            <a:schemeClr val="accent1"/>
-          </a:effectRef>
-          <a:fontRef idx="minor">
-            <a:schemeClr val="lt1"/>
-          </a:fontRef>
-        </p:style>
-        <p:txBody>
-          <a:bodyPr rtlCol="0" anchor="ctr"/>
-          <a:lstStyle/>
-          <a:p>
-            <a:pPr algn="ctr"/>
-          </a:p>
-        </p:txBody>
-      </p:sp>
-      <p:sp>
-        <p:nvSpPr>
-          <p:cNvPr id="23" name="TextBox 22"/>
-          <p:cNvSpPr txBox="1"/>
-          <p:nvPr/>
-        </p:nvSpPr>
-        <p:spPr>
-          <a:xfrm>
-            <a:off x="8174736" y="3749040"/>
-            <a:ext cx="3749039" cy="320040"/>
-          </a:xfrm>
-          <a:prstGeom prst="rect">
-            <a:avLst/>
-          </a:prstGeom>
-          <a:noFill/>
-        </p:spPr>
-        <p:txBody>
-          <a:bodyPr wrap="square">
-            <a:spAutoFit/>
-          </a:bodyPr>
-          <a:lstStyle/>
-          <a:p>
-            <a:pPr algn="l"/>
-            <a:r>
-              <a:rPr sz="900" b="1">
-                <a:solidFill>
-                  <a:srgbClr val="FF9664"/>
-                </a:solidFill>
-              </a:rPr>
-              <a:t>E  NEXT STEPS / REMAINING WORK</a:t>
-            </a:r>
-          </a:p>
-        </p:txBody>
-      </p:sp>
-      <p:sp>
-        <p:nvSpPr>
-          <p:cNvPr id="24" name="TextBox 23"/>
-          <p:cNvSpPr txBox="1"/>
-          <p:nvPr/>
-        </p:nvSpPr>
-        <p:spPr>
-          <a:xfrm>
-            <a:off x="8174736" y="3995928"/>
-            <a:ext cx="3749039" cy="2331720"/>
-          </a:xfrm>
-          <a:prstGeom prst="rect">
-            <a:avLst/>
-          </a:prstGeom>
-          <a:noFill/>
-        </p:spPr>
-        <p:txBody>
-          <a:bodyPr wrap="square">
-            <a:spAutoFit/>
-          </a:bodyPr>
-          <a:lstStyle/>
-          <a:p>
-            <a:pPr algn="l"/>
-            <a:r>
-              <a:rPr sz="1050" b="0">
-                <a:solidFill>
-                  <a:srgbClr val="DCE6FF"/>
-                </a:solidFill>
-              </a:rPr>
-              <a:t>→  RTL / HLS implementation of distance kernel
-→  Cycle-accurate simulation (verify 62× claim)
-→  Power &amp; area analysis (synthesis)
-→  End-to-end integration test (CPU ↔ PIM via UCIe)
-→  Compare simulated vs theoretical throughput
-Success criteria:
-  • End-to-end runtime &lt; 150 ms/image
-  • Interface NOT the bottleneck
-  • Matches roofline prediction within 2×</a:t>
-            </a:r>
-          </a:p>
-        </p:txBody>
-      </p:sp>
-      <p:sp>
-        <p:nvSpPr>
-          <p:cNvPr id="25" name="Rectangle 24"/>
-          <p:cNvSpPr/>
-          <p:nvPr/>
-        </p:nvSpPr>
-        <p:spPr>
-          <a:xfrm>
-            <a:off x="0" y="6629400"/>
-            <a:ext cx="12188952" cy="228600"/>
-          </a:xfrm>
-          <a:prstGeom prst="rect">
-            <a:avLst/>
-          </a:prstGeom>
-          <a:solidFill>
-            <a:srgbClr val="1E3264"/>
-          </a:solidFill>
-          <a:ln>
-            <a:noFill/>
-          </a:ln>
-        </p:spPr>
-        <p:style>
-          <a:lnRef idx="1">
-            <a:schemeClr val="accent1"/>
-          </a:lnRef>
-          <a:fillRef idx="3">
-            <a:schemeClr val="accent1"/>
-          </a:fillRef>
-          <a:effectRef idx="2">
-            <a:schemeClr val="accent1"/>
-          </a:effectRef>
-          <a:fontRef idx="minor">
-            <a:schemeClr val="lt1"/>
-          </a:fontRef>
-        </p:style>
-        <p:txBody>
-          <a:bodyPr rtlCol="0" anchor="ctr"/>
-          <a:lstStyle/>
-          <a:p>
-            <a:pPr algn="ctr"/>
-          </a:p>
-        </p:txBody>
-      </p:sp>
-      <p:sp>
-        <p:nvSpPr>
-          <p:cNvPr id="26" name="TextBox 25"/>
-          <p:cNvSpPr txBox="1"/>
-          <p:nvPr/>
-        </p:nvSpPr>
-        <p:spPr>
-          <a:xfrm>
-            <a:off x="228600" y="6638544"/>
-            <a:ext cx="11887200" cy="201168"/>
-          </a:xfrm>
-          <a:prstGeom prst="rect">
-            <a:avLst/>
-          </a:prstGeom>
-          <a:noFill/>
-        </p:spPr>
-        <p:txBody>
-          <a:bodyPr wrap="square">
-            <a:spAutoFit/>
-          </a:bodyPr>
-          <a:lstStyle/>
-          <a:p>
-            <a:pPr algn="l"/>
-            <a:r>
-              <a:rPr sz="750" b="0">
-                <a:solidFill>
-                  <a:srgbClr val="96AADC"/>
-                </a:solidFill>
-              </a:rPr>
-              <a:t>ECE 410/510 Spring 2026  |  Bao Nguyen  |  baon@pdx.edu  |  K-Means PIM Accelerator</a:t>
-            </a:r>
-          </a:p>
-        </p:txBody>
-      </p:sp>
+      </p:pic>
     </p:spTree>
   </p:cSld>
   <p:clrMapOvr>

</xml_diff>

<commit_message>
slides: replace bliss placeholder with real before/after K-Means result
</commit_message>
<xml_diff>
--- a/codefest/codefest_presentation_bao_nguyen.pptx
+++ b/codefest/codefest_presentation_bao_nguyen.pptx
@@ -3677,7 +3677,7 @@
         <p:spPr>
           <a:xfrm>
             <a:off x="5897880" y="3145536"/>
-            <a:ext cx="3026664" cy="228600"/>
+            <a:ext cx="6144768" cy="228600"/>
           </a:xfrm>
           <a:prstGeom prst="rect">
             <a:avLst/>
@@ -3720,7 +3720,7 @@
         <p:spPr>
           <a:xfrm>
             <a:off x="5943600" y="3163824"/>
-            <a:ext cx="2935224" cy="201168"/>
+            <a:ext cx="6053328" cy="201168"/>
           </a:xfrm>
           <a:prstGeom prst="rect">
             <a:avLst/>
@@ -3740,168 +3740,14 @@
                   <a:srgbClr val="4FC3F7"/>
                 </a:solidFill>
               </a:rPr>
-              <a:t>Before (original)</a:t>
-            </a:r>
-          </a:p>
-        </p:txBody>
-      </p:sp>
-      <p:sp>
-        <p:nvSpPr>
-          <p:cNvPr id="14" name="Rectangle 13"/>
-          <p:cNvSpPr/>
-          <p:nvPr/>
-        </p:nvSpPr>
-        <p:spPr>
-          <a:xfrm>
-            <a:off x="5897880" y="3401568"/>
-            <a:ext cx="3026664" cy="2103120"/>
-          </a:xfrm>
-          <a:prstGeom prst="rect">
-            <a:avLst/>
-          </a:prstGeom>
-          <a:solidFill>
-            <a:srgbClr val="2A2A3E"/>
-          </a:solidFill>
-          <a:ln>
-            <a:noFill/>
-          </a:ln>
-        </p:spPr>
-        <p:style>
-          <a:lnRef idx="1">
-            <a:schemeClr val="accent1"/>
-          </a:lnRef>
-          <a:fillRef idx="3">
-            <a:schemeClr val="accent1"/>
-          </a:fillRef>
-          <a:effectRef idx="2">
-            <a:schemeClr val="accent1"/>
-          </a:effectRef>
-          <a:fontRef idx="minor">
-            <a:schemeClr val="lt1"/>
-          </a:fontRef>
-        </p:style>
-        <p:txBody>
-          <a:bodyPr rtlCol="0" anchor="ctr"/>
-          <a:lstStyle/>
-          <a:p>
-            <a:pPr algn="ctr"/>
-          </a:p>
-        </p:txBody>
-      </p:sp>
-      <p:sp>
-        <p:nvSpPr>
-          <p:cNvPr id="15" name="TextBox 14"/>
-          <p:cNvSpPr txBox="1"/>
-          <p:nvPr/>
-        </p:nvSpPr>
-        <p:spPr>
-          <a:xfrm>
-            <a:off x="6080760" y="4270248"/>
-            <a:ext cx="2660904" cy="365760"/>
-          </a:xfrm>
-          <a:prstGeom prst="rect">
-            <a:avLst/>
-          </a:prstGeom>
-          <a:noFill/>
-        </p:spPr>
-        <p:txBody>
-          <a:bodyPr wrap="square">
-            <a:spAutoFit/>
-          </a:bodyPr>
-          <a:lstStyle/>
-          <a:p>
-            <a:pPr algn="ctr"/>
-            <a:r>
-              <a:rPr sz="800" b="0">
-                <a:solidFill>
-                  <a:srgbClr val="8888AA"/>
-                </a:solidFill>
-              </a:rPr>
-              <a:t>← add bliss_original.jpg</a:t>
-            </a:r>
-          </a:p>
-        </p:txBody>
-      </p:sp>
-      <p:sp>
-        <p:nvSpPr>
-          <p:cNvPr id="16" name="Rectangle 15"/>
-          <p:cNvSpPr/>
-          <p:nvPr/>
-        </p:nvSpPr>
-        <p:spPr>
-          <a:xfrm>
-            <a:off x="9015984" y="3145536"/>
-            <a:ext cx="3026664" cy="228600"/>
-          </a:xfrm>
-          <a:prstGeom prst="rect">
-            <a:avLst/>
-          </a:prstGeom>
-          <a:solidFill>
-            <a:srgbClr val="0F3D5C"/>
-          </a:solidFill>
-          <a:ln>
-            <a:noFill/>
-          </a:ln>
-        </p:spPr>
-        <p:style>
-          <a:lnRef idx="1">
-            <a:schemeClr val="accent1"/>
-          </a:lnRef>
-          <a:fillRef idx="3">
-            <a:schemeClr val="accent1"/>
-          </a:fillRef>
-          <a:effectRef idx="2">
-            <a:schemeClr val="accent1"/>
-          </a:effectRef>
-          <a:fontRef idx="minor">
-            <a:schemeClr val="lt1"/>
-          </a:fontRef>
-        </p:style>
-        <p:txBody>
-          <a:bodyPr rtlCol="0" anchor="ctr"/>
-          <a:lstStyle/>
-          <a:p>
-            <a:pPr algn="ctr"/>
-          </a:p>
-        </p:txBody>
-      </p:sp>
-      <p:sp>
-        <p:nvSpPr>
-          <p:cNvPr id="17" name="TextBox 16"/>
-          <p:cNvSpPr txBox="1"/>
-          <p:nvPr/>
-        </p:nvSpPr>
-        <p:spPr>
-          <a:xfrm>
-            <a:off x="9061704" y="3163824"/>
-            <a:ext cx="2935224" cy="201168"/>
-          </a:xfrm>
-          <a:prstGeom prst="rect">
-            <a:avLst/>
-          </a:prstGeom>
-          <a:noFill/>
-        </p:spPr>
-        <p:txBody>
-          <a:bodyPr wrap="square">
-            <a:spAutoFit/>
-          </a:bodyPr>
-          <a:lstStyle/>
-          <a:p>
-            <a:pPr algn="l"/>
-            <a:r>
-              <a:rPr sz="800" b="1">
-                <a:solidFill>
-                  <a:srgbClr val="4FC3F7"/>
-                </a:solidFill>
-              </a:rPr>
-              <a:t>After (16 colors, K-Means)</a:t>
+              <a:t>Bliss — Original vs K-Means (K=16 colors)</a:t>
             </a:r>
           </a:p>
         </p:txBody>
       </p:sp>
       <p:pic>
         <p:nvPicPr>
-          <p:cNvPr id="18" name="Picture 17" descr="bliss_quantized.png"/>
+          <p:cNvPr id="14" name="Picture 13" descr="bliss_before_after.png"/>
           <p:cNvPicPr>
             <a:picLocks noChangeAspect="1"/>
           </p:cNvPicPr>
@@ -3915,8 +3761,8 @@
         </p:blipFill>
         <p:spPr>
           <a:xfrm>
-            <a:off x="9015984" y="3401568"/>
-            <a:ext cx="3026664" cy="2103120"/>
+            <a:off x="5897880" y="3401568"/>
+            <a:ext cx="6144768" cy="2103120"/>
           </a:xfrm>
           <a:prstGeom prst="rect">
             <a:avLst/>
@@ -3925,7 +3771,7 @@
       </p:pic>
       <p:sp>
         <p:nvSpPr>
-          <p:cNvPr id="19" name="Rectangle 18"/>
+          <p:cNvPr id="15" name="Rectangle 14"/>
           <p:cNvSpPr/>
           <p:nvPr/>
         </p:nvSpPr>
@@ -3968,7 +3814,7 @@
       </p:sp>
       <p:sp>
         <p:nvSpPr>
-          <p:cNvPr id="20" name="TextBox 19"/>
+          <p:cNvPr id="16" name="TextBox 15"/>
           <p:cNvSpPr txBox="1"/>
           <p:nvPr/>
         </p:nvSpPr>
@@ -4002,7 +3848,7 @@
       </p:sp>
       <p:pic>
         <p:nvPicPr>
-          <p:cNvPr id="21" name="Picture 20" descr="system_diagram.png"/>
+          <p:cNvPr id="17" name="Picture 16" descr="system_diagram.png"/>
           <p:cNvPicPr>
             <a:picLocks noChangeAspect="1"/>
           </p:cNvPicPr>

</xml_diff>

<commit_message>
slides: fix layout — correct aspect ratios, breathing room between images
</commit_message>
<xml_diff>
--- a/codefest/codefest_presentation_bao_nguyen.pptx
+++ b/codefest/codefest_presentation_bao_nguyen.pptx
@@ -3105,13 +3105,13 @@
         <p:spPr>
           <a:xfrm>
             <a:off x="0" y="0"/>
-            <a:ext cx="12188952" cy="640080"/>
+            <a:ext cx="12188952" cy="566928"/>
           </a:xfrm>
           <a:prstGeom prst="rect">
             <a:avLst/>
           </a:prstGeom>
           <a:solidFill>
-            <a:srgbClr val="16213E"/>
+            <a:srgbClr val="0F1E40"/>
           </a:solidFill>
           <a:ln>
             <a:noFill/>
@@ -3147,8 +3147,8 @@
         </p:nvSpPr>
         <p:spPr>
           <a:xfrm>
-            <a:off x="137160" y="45720"/>
-            <a:ext cx="8229600" cy="548640"/>
+            <a:off x="137160" y="54864"/>
+            <a:ext cx="8229600" cy="475488"/>
           </a:xfrm>
           <a:prstGeom prst="rect">
             <a:avLst/>
@@ -3163,7 +3163,7 @@
           <a:p>
             <a:pPr algn="l"/>
             <a:r>
-              <a:rPr sz="2000" b="1">
+              <a:rPr sz="1900" b="1">
                 <a:solidFill>
                   <a:srgbClr val="FFFFFF"/>
                 </a:solidFill>
@@ -3181,8 +3181,8 @@
         </p:nvSpPr>
         <p:spPr>
           <a:xfrm>
-            <a:off x="8686800" y="45720"/>
-            <a:ext cx="3383280" cy="548640"/>
+            <a:off x="8412480" y="91440"/>
+            <a:ext cx="3657600" cy="402336"/>
           </a:xfrm>
           <a:prstGeom prst="rect">
             <a:avLst/>
@@ -3197,7 +3197,7 @@
           <a:p>
             <a:pPr algn="r"/>
             <a:r>
-              <a:rPr sz="1000" b="0">
+              <a:rPr sz="900" b="0">
                 <a:solidFill>
                   <a:srgbClr val="AABBCC"/>
                 </a:solidFill>
@@ -3215,14 +3215,14 @@
         </p:nvSpPr>
         <p:spPr>
           <a:xfrm>
-            <a:off x="137160" y="713232"/>
-            <a:ext cx="1417320" cy="868680"/>
+            <a:off x="137160" y="640080"/>
+            <a:ext cx="1325880" cy="749808"/>
           </a:xfrm>
           <a:prstGeom prst="rect">
             <a:avLst/>
           </a:prstGeom>
           <a:solidFill>
-            <a:srgbClr val="E83E3E"/>
+            <a:srgbClr val="C0392B"/>
           </a:solidFill>
           <a:ln>
             <a:noFill/>
@@ -3258,8 +3258,8 @@
         </p:nvSpPr>
         <p:spPr>
           <a:xfrm>
-            <a:off x="137160" y="713232"/>
-            <a:ext cx="1417320" cy="502920"/>
+            <a:off x="137160" y="640080"/>
+            <a:ext cx="1325880" cy="457200"/>
           </a:xfrm>
           <a:prstGeom prst="rect">
             <a:avLst/>
@@ -3274,7 +3274,7 @@
           <a:p>
             <a:pPr algn="ctr"/>
             <a:r>
-              <a:rPr sz="3400" b="1">
+              <a:rPr sz="3000" b="1">
                 <a:solidFill>
                   <a:srgbClr val="FFFFFF"/>
                 </a:solidFill>
@@ -3292,8 +3292,8 @@
         </p:nvSpPr>
         <p:spPr>
           <a:xfrm>
-            <a:off x="137160" y="1170432"/>
-            <a:ext cx="1417320" cy="384048"/>
+            <a:off x="137160" y="1060704"/>
+            <a:ext cx="1325880" cy="292608"/>
           </a:xfrm>
           <a:prstGeom prst="rect">
             <a:avLst/>
@@ -3308,13 +3308,12 @@
           <a:p>
             <a:pPr algn="ctr"/>
             <a:r>
-              <a:rPr sz="800" b="0">
+              <a:rPr sz="750" b="0">
                 <a:solidFill>
-                  <a:srgbClr val="FFFFFF"/>
+                  <a:srgbClr val="FFDCDC"/>
                 </a:solidFill>
               </a:rPr>
-              <a:t>projected
-speedup</a:t>
+              <a:t>projected speedup</a:t>
             </a:r>
           </a:p>
         </p:txBody>
@@ -3327,8 +3326,8 @@
         </p:nvSpPr>
         <p:spPr>
           <a:xfrm>
-            <a:off x="1664208" y="685800"/>
-            <a:ext cx="4069080" cy="5943600"/>
+            <a:off x="137160" y="1481328"/>
+            <a:ext cx="3886200" cy="5120640"/>
           </a:xfrm>
           <a:prstGeom prst="rect">
             <a:avLst/>
@@ -3342,227 +3341,212 @@
           <a:lstStyle/>
           <a:p>
             <a:pPr>
-              <a:spcAft>
-                <a:spcPts val="200"/>
-              </a:spcAft>
+              <a:spcBef>
+                <a:spcPts val="500"/>
+              </a:spcBef>
             </a:pPr>
             <a:r>
               <a:rPr sz="950" b="1">
                 <a:solidFill>
-                  <a:srgbClr val="FFFFFF"/>
+                  <a:srgbClr val="4FC3F7"/>
                 </a:solidFill>
               </a:rPr>
               <a:t>What am I doing?</a:t>
             </a:r>
           </a:p>
           <a:p>
-            <a:pPr lvl="1">
-              <a:spcAft>
-                <a:spcPts val="200"/>
-              </a:spcAft>
+            <a:pPr>
+              <a:spcBef>
+                <a:spcPts val="100"/>
+              </a:spcBef>
             </a:pPr>
             <a:r>
-              <a:rPr sz="900" b="0">
+              <a:rPr sz="850" b="0">
                 <a:solidFill>
-                  <a:srgbClr val="D2D2D2"/>
+                  <a:srgbClr val="DDDDDD"/>
                 </a:solidFill>
               </a:rPr>
-              <a:t>• Custom chip: reduces any photo to 16 colors by grouping similar pixels</a:t>
+              <a:t>  • Custom chip that reduces any photo to 16 colors by grouping similar pixels</a:t>
             </a:r>
           </a:p>
           <a:p>
             <a:pPr>
-              <a:spcAft>
-                <a:spcPts val="200"/>
-              </a:spcAft>
+              <a:spcBef>
+                <a:spcPts val="500"/>
+              </a:spcBef>
             </a:pPr>
             <a:r>
               <a:rPr sz="950" b="1">
                 <a:solidFill>
-                  <a:srgbClr val="FFFFFF"/>
+                  <a:srgbClr val="4FC3F7"/>
                 </a:solidFill>
               </a:rPr>
               <a:t>How is it done today?</a:t>
             </a:r>
           </a:p>
           <a:p>
-            <a:pPr lvl="1">
-              <a:spcAft>
-                <a:spcPts val="200"/>
-              </a:spcAft>
+            <a:pPr>
+              <a:spcBef>
+                <a:spcPts val="100"/>
+              </a:spcBef>
             </a:pPr>
             <a:r>
-              <a:rPr sz="900" b="0">
+              <a:rPr sz="850" b="0">
                 <a:solidFill>
-                  <a:srgbClr val="D2D2D2"/>
+                  <a:srgbClr val="DDDDDD"/>
                 </a:solidFill>
               </a:rPr>
-              <a:t>• Runs on CPU — ~9 sec/image, using &lt;1% of CPU computing power</a:t>
-            </a:r>
-          </a:p>
-          <a:p>
-            <a:pPr lvl="1">
-              <a:spcAft>
-                <a:spcPts val="200"/>
-              </a:spcAft>
+              <a:t>  • Runs on CPU — ~9 sec/image, using &lt;1% of computing power</a:t>
+            </a:r>
+          </a:p>
+          <a:p>
+            <a:pPr>
+              <a:spcBef>
+                <a:spcPts val="100"/>
+              </a:spcBef>
             </a:pPr>
             <a:r>
-              <a:rPr sz="900" b="0">
+              <a:rPr sz="850" b="0">
                 <a:solidFill>
-                  <a:srgbClr val="D2D2D2"/>
+                  <a:srgbClr val="DDDDDD"/>
                 </a:solidFill>
               </a:rPr>
-              <a:t>• Bottleneck is memory: CPU waits for data, not doing math (46% of runtime)</a:t>
+              <a:t>  • Bottleneck is memory: 46% of runtime just waiting for data</a:t>
             </a:r>
           </a:p>
           <a:p>
             <a:pPr>
-              <a:spcAft>
-                <a:spcPts val="200"/>
-              </a:spcAft>
+              <a:spcBef>
+                <a:spcPts val="500"/>
+              </a:spcBef>
             </a:pPr>
             <a:r>
               <a:rPr sz="950" b="1">
                 <a:solidFill>
-                  <a:srgbClr val="FFFFFF"/>
+                  <a:srgbClr val="4FC3F7"/>
                 </a:solidFill>
               </a:rPr>
               <a:t>What am I doing differently?</a:t>
             </a:r>
           </a:p>
           <a:p>
-            <a:pPr lvl="1">
-              <a:spcAft>
-                <a:spcPts val="200"/>
-              </a:spcAft>
+            <a:pPr>
+              <a:spcBef>
+                <a:spcPts val="100"/>
+              </a:spcBef>
             </a:pPr>
             <a:r>
-              <a:rPr sz="900" b="0">
+              <a:rPr sz="850" b="0">
                 <a:solidFill>
-                  <a:srgbClr val="D2D2D2"/>
+                  <a:srgbClr val="DDDDDD"/>
                 </a:solidFill>
               </a:rPr>
-              <a:t>• Memory &amp; math units side-by-side — no waiting (near-memory PIM chiplet)</a:t>
-            </a:r>
-          </a:p>
-          <a:p>
-            <a:pPr lvl="1">
-              <a:spcAft>
-                <a:spcPts val="200"/>
-              </a:spcAft>
+              <a:t>  • Memory &amp; math sit side-by-side — no waiting (near-memory PIM chiplet)</a:t>
+            </a:r>
+          </a:p>
+          <a:p>
+            <a:pPr>
+              <a:spcBef>
+                <a:spcPts val="100"/>
+              </a:spcBef>
             </a:pPr>
             <a:r>
-              <a:rPr sz="900" b="0">
+              <a:rPr sz="850" b="0">
                 <a:solidFill>
-                  <a:srgbClr val="D2D2D2"/>
+                  <a:srgbClr val="DDDDDD"/>
                 </a:solidFill>
               </a:rPr>
-              <a:t>• 16 TB/s internal bandwidth vs CPU — ~62× speedup</a:t>
+              <a:t>  • 16 TB/s internal bandwidth vs CPU → 62× speedup</a:t>
             </a:r>
           </a:p>
           <a:p>
             <a:pPr>
-              <a:spcAft>
-                <a:spcPts val="200"/>
-              </a:spcAft>
+              <a:spcBef>
+                <a:spcPts val="500"/>
+              </a:spcBef>
             </a:pPr>
             <a:r>
               <a:rPr sz="950" b="1">
                 <a:solidFill>
-                  <a:srgbClr val="FFFFFF"/>
+                  <a:srgbClr val="4FC3F7"/>
                 </a:solidFill>
               </a:rPr>
               <a:t>Accomplished so far</a:t>
             </a:r>
           </a:p>
           <a:p>
-            <a:pPr lvl="1">
-              <a:spcAft>
-                <a:spcPts val="200"/>
-              </a:spcAft>
+            <a:pPr>
+              <a:spcBef>
+                <a:spcPts val="100"/>
+              </a:spcBef>
             </a:pPr>
             <a:r>
-              <a:rPr sz="900" b="0">
+              <a:rPr sz="850" b="0">
                 <a:solidFill>
-                  <a:srgbClr val="D2D2D2"/>
+                  <a:srgbClr val="DDDDDD"/>
                 </a:solidFill>
               </a:rPr>
-              <a:t>• Benchmarked CPU baseline, confirmed memory bottleneck</a:t>
-            </a:r>
-          </a:p>
-          <a:p>
-            <a:pPr lvl="1">
-              <a:spcAft>
-                <a:spcPts val="200"/>
-              </a:spcAft>
+              <a:t>  • Benchmarked CPU baseline, confirmed memory bottleneck</a:t>
+            </a:r>
+          </a:p>
+          <a:p>
+            <a:pPr>
+              <a:spcBef>
+                <a:spcPts val="100"/>
+              </a:spcBef>
             </a:pPr>
             <a:r>
-              <a:rPr sz="900" b="0">
+              <a:rPr sz="850" b="0">
                 <a:solidFill>
-                  <a:srgbClr val="D2D2D2"/>
+                  <a:srgbClr val="DDDDDD"/>
                 </a:solidFill>
               </a:rPr>
-              <a:t>• Wrote &amp; simulated all hardware — distance engine, AXI4-Lite interface,</a:t>
-            </a:r>
-          </a:p>
-          <a:p>
-            <a:pPr lvl="1">
-              <a:spcAft>
-                <a:spcPts val="200"/>
-              </a:spcAft>
-            </a:pPr>
-            <a:r>
-              <a:rPr sz="900" b="0">
-                <a:solidFill>
-                  <a:srgbClr val="D2D2D2"/>
-                </a:solidFill>
-              </a:rPr>
-              <a:t>•   compute core — all passing testbenches</a:t>
+              <a:t>  • Distance engine, AXI4-Lite interface &amp; compute core — all passing simulation</a:t>
             </a:r>
           </a:p>
           <a:p>
             <a:pPr>
-              <a:spcAft>
-                <a:spcPts val="200"/>
-              </a:spcAft>
+              <a:spcBef>
+                <a:spcPts val="500"/>
+              </a:spcBef>
             </a:pPr>
             <a:r>
               <a:rPr sz="950" b="1">
                 <a:solidFill>
-                  <a:srgbClr val="FFFFFF"/>
+                  <a:srgbClr val="4FC3F7"/>
                 </a:solidFill>
               </a:rPr>
               <a:t>What's next?</a:t>
             </a:r>
           </a:p>
           <a:p>
-            <a:pPr lvl="1">
-              <a:spcAft>
-                <a:spcPts val="200"/>
-              </a:spcAft>
+            <a:pPr>
+              <a:spcBef>
+                <a:spcPts val="100"/>
+              </a:spcBef>
             </a:pPr>
             <a:r>
-              <a:rPr sz="900" b="0">
+              <a:rPr sz="850" b="0">
                 <a:solidFill>
-                  <a:srgbClr val="D2D2D2"/>
+                  <a:srgbClr val="DDDDDD"/>
                 </a:solidFill>
               </a:rPr>
-              <a:t>• Connect pieces into full system, verify timing,</a:t>
-            </a:r>
-          </a:p>
-          <a:p>
-            <a:pPr lvl="1">
-              <a:spcAft>
-                <a:spcPts val="200"/>
-              </a:spcAft>
+              <a:t>  • Connect pieces into full system, verify timing</a:t>
+            </a:r>
+          </a:p>
+          <a:p>
+            <a:pPr>
+              <a:spcBef>
+                <a:spcPts val="100"/>
+              </a:spcBef>
             </a:pPr>
             <a:r>
-              <a:rPr sz="900" b="0">
+              <a:rPr sz="850" b="0">
                 <a:solidFill>
-                  <a:srgbClr val="D2D2D2"/>
+                  <a:srgbClr val="DDDDDD"/>
                 </a:solidFill>
               </a:rPr>
-              <a:t>•   compare throughput vs 9-sec baseline → declare success</a:t>
+              <a:t>  • Compare throughput vs 9-sec baseline → declare success</a:t>
             </a:r>
           </a:p>
         </p:txBody>
@@ -3575,14 +3559,14 @@
         </p:nvSpPr>
         <p:spPr>
           <a:xfrm>
-            <a:off x="5897880" y="685800"/>
-            <a:ext cx="6144768" cy="228600"/>
+            <a:off x="4187952" y="640080"/>
+            <a:ext cx="3877056" cy="201168"/>
           </a:xfrm>
           <a:prstGeom prst="rect">
             <a:avLst/>
           </a:prstGeom>
           <a:solidFill>
-            <a:srgbClr val="0F3D5C"/>
+            <a:srgbClr val="0D3B5E"/>
           </a:solidFill>
           <a:ln>
             <a:noFill/>
@@ -3618,8 +3602,8 @@
         </p:nvSpPr>
         <p:spPr>
           <a:xfrm>
-            <a:off x="5943600" y="704088"/>
-            <a:ext cx="6053328" cy="201168"/>
+            <a:off x="4242816" y="658368"/>
+            <a:ext cx="3767328" cy="182880"/>
           </a:xfrm>
           <a:prstGeom prst="rect">
             <a:avLst/>
@@ -3634,12 +3618,12 @@
           <a:p>
             <a:pPr algn="l"/>
             <a:r>
-              <a:rPr sz="800" b="1">
+              <a:rPr sz="750" b="1">
                 <a:solidFill>
                   <a:srgbClr val="4FC3F7"/>
                 </a:solidFill>
               </a:rPr>
-              <a:t>Roofline: CPU vs PIM Accelerator</a:t>
+              <a:t>Roofline — CPU vs PIM Accelerator</a:t>
             </a:r>
           </a:p>
         </p:txBody>
@@ -3660,8 +3644,8 @@
         </p:blipFill>
         <p:spPr>
           <a:xfrm>
-            <a:off x="5897880" y="932688"/>
-            <a:ext cx="6144768" cy="2331720"/>
+            <a:off x="4187952" y="850392"/>
+            <a:ext cx="3877056" cy="2442783"/>
           </a:xfrm>
           <a:prstGeom prst="rect">
             <a:avLst/>
@@ -3676,14 +3660,14 @@
         </p:nvSpPr>
         <p:spPr>
           <a:xfrm>
-            <a:off x="5897880" y="3145536"/>
-            <a:ext cx="6144768" cy="228600"/>
+            <a:off x="8174736" y="640080"/>
+            <a:ext cx="3877056" cy="201168"/>
           </a:xfrm>
           <a:prstGeom prst="rect">
             <a:avLst/>
           </a:prstGeom>
           <a:solidFill>
-            <a:srgbClr val="0F3D5C"/>
+            <a:srgbClr val="0D3B5E"/>
           </a:solidFill>
           <a:ln>
             <a:noFill/>
@@ -3719,8 +3703,8 @@
         </p:nvSpPr>
         <p:spPr>
           <a:xfrm>
-            <a:off x="5943600" y="3163824"/>
-            <a:ext cx="6053328" cy="201168"/>
+            <a:off x="8229600" y="658368"/>
+            <a:ext cx="3767328" cy="182880"/>
           </a:xfrm>
           <a:prstGeom prst="rect">
             <a:avLst/>
@@ -3735,19 +3719,19 @@
           <a:p>
             <a:pPr algn="l"/>
             <a:r>
-              <a:rPr sz="800" b="1">
+              <a:rPr sz="750" b="1">
                 <a:solidFill>
                   <a:srgbClr val="4FC3F7"/>
                 </a:solidFill>
               </a:rPr>
-              <a:t>Bliss — Original vs K-Means (K=16 colors)</a:t>
+              <a:t>System Architecture</a:t>
             </a:r>
           </a:p>
         </p:txBody>
       </p:sp>
       <p:pic>
         <p:nvPicPr>
-          <p:cNvPr id="14" name="Picture 13" descr="bliss_before_after.png"/>
+          <p:cNvPr id="14" name="Picture 13" descr="system_diagram.png"/>
           <p:cNvPicPr>
             <a:picLocks noChangeAspect="1"/>
           </p:cNvPicPr>
@@ -3761,8 +3745,8 @@
         </p:blipFill>
         <p:spPr>
           <a:xfrm>
-            <a:off x="5897880" y="3401568"/>
-            <a:ext cx="6144768" cy="2103120"/>
+            <a:off x="8174736" y="850392"/>
+            <a:ext cx="3877056" cy="1924581"/>
           </a:xfrm>
           <a:prstGeom prst="rect">
             <a:avLst/>
@@ -3777,14 +3761,14 @@
         </p:nvSpPr>
         <p:spPr>
           <a:xfrm>
-            <a:off x="5897880" y="5577840"/>
-            <a:ext cx="6144768" cy="228600"/>
+            <a:off x="4187952" y="3457767"/>
+            <a:ext cx="7863840" cy="201168"/>
           </a:xfrm>
           <a:prstGeom prst="rect">
             <a:avLst/>
           </a:prstGeom>
           <a:solidFill>
-            <a:srgbClr val="0F3D5C"/>
+            <a:srgbClr val="0D3B5E"/>
           </a:solidFill>
           <a:ln>
             <a:noFill/>
@@ -3820,8 +3804,8 @@
         </p:nvSpPr>
         <p:spPr>
           <a:xfrm>
-            <a:off x="5943600" y="5596127"/>
-            <a:ext cx="6053328" cy="201168"/>
+            <a:off x="4242816" y="3476055"/>
+            <a:ext cx="7754112" cy="182880"/>
           </a:xfrm>
           <a:prstGeom prst="rect">
             <a:avLst/>
@@ -3836,19 +3820,19 @@
           <a:p>
             <a:pPr algn="l"/>
             <a:r>
-              <a:rPr sz="800" b="1">
+              <a:rPr sz="750" b="1">
                 <a:solidFill>
                   <a:srgbClr val="4FC3F7"/>
                 </a:solidFill>
               </a:rPr>
-              <a:t>System Architecture</a:t>
+              <a:t>Bliss.jpg — Original (left) vs K-Means K=16 colors (right)</a:t>
             </a:r>
           </a:p>
         </p:txBody>
       </p:sp>
       <p:pic>
         <p:nvPicPr>
-          <p:cNvPr id="17" name="Picture 16" descr="system_diagram.png"/>
+          <p:cNvPr id="17" name="Picture 16" descr="bliss_before_after.png"/>
           <p:cNvPicPr>
             <a:picLocks noChangeAspect="1"/>
           </p:cNvPicPr>
@@ -3862,8 +3846,8 @@
         </p:blipFill>
         <p:spPr>
           <a:xfrm>
-            <a:off x="5897880" y="5824728"/>
-            <a:ext cx="6144768" cy="914400"/>
+            <a:off x="4187952" y="3668079"/>
+            <a:ext cx="7863840" cy="3174842"/>
           </a:xfrm>
           <a:prstGeom prst="rect">
             <a:avLst/>

</xml_diff>

<commit_message>
slides: fix image sizing — aspect-ratio locked, properly fills slide
</commit_message>
<xml_diff>
--- a/codefest/codefest_presentation_bao_nguyen.pptx
+++ b/codefest/codefest_presentation_bao_nguyen.pptx
@@ -3216,7 +3216,7 @@
         <p:spPr>
           <a:xfrm>
             <a:off x="137160" y="640080"/>
-            <a:ext cx="1325880" cy="749808"/>
+            <a:ext cx="1234440" cy="685800"/>
           </a:xfrm>
           <a:prstGeom prst="rect">
             <a:avLst/>
@@ -3259,7 +3259,7 @@
         <p:spPr>
           <a:xfrm>
             <a:off x="137160" y="640080"/>
-            <a:ext cx="1325880" cy="457200"/>
+            <a:ext cx="1234440" cy="438912"/>
           </a:xfrm>
           <a:prstGeom prst="rect">
             <a:avLst/>
@@ -3274,7 +3274,7 @@
           <a:p>
             <a:pPr algn="ctr"/>
             <a:r>
-              <a:rPr sz="3000" b="1">
+              <a:rPr sz="2800" b="1">
                 <a:solidFill>
                   <a:srgbClr val="FFFFFF"/>
                 </a:solidFill>
@@ -3292,8 +3292,8 @@
         </p:nvSpPr>
         <p:spPr>
           <a:xfrm>
-            <a:off x="137160" y="1060704"/>
-            <a:ext cx="1325880" cy="292608"/>
+            <a:off x="137160" y="1042415"/>
+            <a:ext cx="1234440" cy="256032"/>
           </a:xfrm>
           <a:prstGeom prst="rect">
             <a:avLst/>
@@ -3308,7 +3308,7 @@
           <a:p>
             <a:pPr algn="ctr"/>
             <a:r>
-              <a:rPr sz="750" b="0">
+              <a:rPr sz="700" b="0">
                 <a:solidFill>
                   <a:srgbClr val="FFDCDC"/>
                 </a:solidFill>
@@ -3326,8 +3326,8 @@
         </p:nvSpPr>
         <p:spPr>
           <a:xfrm>
-            <a:off x="137160" y="1481328"/>
-            <a:ext cx="3886200" cy="5120640"/>
+            <a:off x="137160" y="1417319"/>
+            <a:ext cx="2606040" cy="5303520"/>
           </a:xfrm>
           <a:prstGeom prst="rect">
             <a:avLst/>
@@ -3342,11 +3342,11 @@
           <a:p>
             <a:pPr>
               <a:spcBef>
-                <a:spcPts val="500"/>
+                <a:spcPts val="600"/>
               </a:spcBef>
             </a:pPr>
             <a:r>
-              <a:rPr sz="950" b="1">
+              <a:rPr sz="900" b="1">
                 <a:solidFill>
                   <a:srgbClr val="4FC3F7"/>
                 </a:solidFill>
@@ -3361,22 +3361,22 @@
               </a:spcBef>
             </a:pPr>
             <a:r>
-              <a:rPr sz="850" b="0">
+              <a:rPr sz="800" b="0">
                 <a:solidFill>
                   <a:srgbClr val="DDDDDD"/>
                 </a:solidFill>
               </a:rPr>
-              <a:t>  • Custom chip that reduces any photo to 16 colors by grouping similar pixels</a:t>
+              <a:t>  • Custom chip: reduces any photo to 16 colors by grouping similar pixels</a:t>
             </a:r>
           </a:p>
           <a:p>
             <a:pPr>
               <a:spcBef>
-                <a:spcPts val="500"/>
+                <a:spcPts val="600"/>
               </a:spcBef>
             </a:pPr>
             <a:r>
-              <a:rPr sz="950" b="1">
+              <a:rPr sz="900" b="1">
                 <a:solidFill>
                   <a:srgbClr val="4FC3F7"/>
                 </a:solidFill>
@@ -3391,12 +3391,12 @@
               </a:spcBef>
             </a:pPr>
             <a:r>
-              <a:rPr sz="850" b="0">
+              <a:rPr sz="800" b="0">
                 <a:solidFill>
                   <a:srgbClr val="DDDDDD"/>
                 </a:solidFill>
               </a:rPr>
-              <a:t>  • Runs on CPU — ~9 sec/image, using &lt;1% of computing power</a:t>
+              <a:t>  • CPU takes ~9 sec/image using &lt;1% of its power</a:t>
             </a:r>
           </a:p>
           <a:p>
@@ -3406,22 +3406,22 @@
               </a:spcBef>
             </a:pPr>
             <a:r>
-              <a:rPr sz="850" b="0">
+              <a:rPr sz="800" b="0">
                 <a:solidFill>
                   <a:srgbClr val="DDDDDD"/>
                 </a:solidFill>
               </a:rPr>
-              <a:t>  • Bottleneck is memory: 46% of runtime just waiting for data</a:t>
+              <a:t>  • 46% of runtime spent waiting for data from memory</a:t>
             </a:r>
           </a:p>
           <a:p>
             <a:pPr>
               <a:spcBef>
-                <a:spcPts val="500"/>
+                <a:spcPts val="600"/>
               </a:spcBef>
             </a:pPr>
             <a:r>
-              <a:rPr sz="950" b="1">
+              <a:rPr sz="900" b="1">
                 <a:solidFill>
                   <a:srgbClr val="4FC3F7"/>
                 </a:solidFill>
@@ -3436,12 +3436,12 @@
               </a:spcBef>
             </a:pPr>
             <a:r>
-              <a:rPr sz="850" b="0">
+              <a:rPr sz="800" b="0">
                 <a:solidFill>
                   <a:srgbClr val="DDDDDD"/>
                 </a:solidFill>
               </a:rPr>
-              <a:t>  • Memory &amp; math sit side-by-side — no waiting (near-memory PIM chiplet)</a:t>
+              <a:t>  • Memory &amp; math sit side-by-side — no waiting</a:t>
             </a:r>
           </a:p>
           <a:p>
@@ -3451,22 +3451,22 @@
               </a:spcBef>
             </a:pPr>
             <a:r>
-              <a:rPr sz="850" b="0">
+              <a:rPr sz="800" b="0">
                 <a:solidFill>
                   <a:srgbClr val="DDDDDD"/>
                 </a:solidFill>
               </a:rPr>
-              <a:t>  • 16 TB/s internal bandwidth vs CPU → 62× speedup</a:t>
+              <a:t>  • 16 TB/s bandwidth → ~62× speedup</a:t>
             </a:r>
           </a:p>
           <a:p>
             <a:pPr>
               <a:spcBef>
-                <a:spcPts val="500"/>
+                <a:spcPts val="600"/>
               </a:spcBef>
             </a:pPr>
             <a:r>
-              <a:rPr sz="950" b="1">
+              <a:rPr sz="900" b="1">
                 <a:solidFill>
                   <a:srgbClr val="4FC3F7"/>
                 </a:solidFill>
@@ -3481,12 +3481,12 @@
               </a:spcBef>
             </a:pPr>
             <a:r>
-              <a:rPr sz="850" b="0">
+              <a:rPr sz="800" b="0">
                 <a:solidFill>
                   <a:srgbClr val="DDDDDD"/>
                 </a:solidFill>
               </a:rPr>
-              <a:t>  • Benchmarked CPU baseline, confirmed memory bottleneck</a:t>
+              <a:t>  • Benchmarked CPU baseline, found bottleneck</a:t>
             </a:r>
           </a:p>
           <a:p>
@@ -3496,22 +3496,22 @@
               </a:spcBef>
             </a:pPr>
             <a:r>
-              <a:rPr sz="850" b="0">
+              <a:rPr sz="800" b="0">
                 <a:solidFill>
                   <a:srgbClr val="DDDDDD"/>
                 </a:solidFill>
               </a:rPr>
-              <a:t>  • Distance engine, AXI4-Lite interface &amp; compute core — all passing simulation</a:t>
+              <a:t>  • Distance engine, AXI4-Lite &amp; compute core all passing sim</a:t>
             </a:r>
           </a:p>
           <a:p>
             <a:pPr>
               <a:spcBef>
-                <a:spcPts val="500"/>
+                <a:spcPts val="600"/>
               </a:spcBef>
             </a:pPr>
             <a:r>
-              <a:rPr sz="950" b="1">
+              <a:rPr sz="900" b="1">
                 <a:solidFill>
                   <a:srgbClr val="4FC3F7"/>
                 </a:solidFill>
@@ -3526,12 +3526,12 @@
               </a:spcBef>
             </a:pPr>
             <a:r>
-              <a:rPr sz="850" b="0">
+              <a:rPr sz="800" b="0">
                 <a:solidFill>
                   <a:srgbClr val="DDDDDD"/>
                 </a:solidFill>
               </a:rPr>
-              <a:t>  • Connect pieces into full system, verify timing</a:t>
+              <a:t>  • Full system integration + timing verification</a:t>
             </a:r>
           </a:p>
           <a:p>
@@ -3541,12 +3541,12 @@
               </a:spcBef>
             </a:pPr>
             <a:r>
-              <a:rPr sz="850" b="0">
+              <a:rPr sz="800" b="0">
                 <a:solidFill>
                   <a:srgbClr val="DDDDDD"/>
                 </a:solidFill>
               </a:rPr>
-              <a:t>  • Compare throughput vs 9-sec baseline → declare success</a:t>
+              <a:t>  • Compare vs 9-sec baseline → declare success</a:t>
             </a:r>
           </a:p>
         </p:txBody>
@@ -3559,8 +3559,8 @@
         </p:nvSpPr>
         <p:spPr>
           <a:xfrm>
-            <a:off x="4187952" y="640080"/>
-            <a:ext cx="3877056" cy="201168"/>
+            <a:off x="2926080" y="640080"/>
+            <a:ext cx="3628218" cy="201168"/>
           </a:xfrm>
           <a:prstGeom prst="rect">
             <a:avLst/>
@@ -3602,8 +3602,8 @@
         </p:nvSpPr>
         <p:spPr>
           <a:xfrm>
-            <a:off x="4242816" y="658368"/>
-            <a:ext cx="3767328" cy="182880"/>
+            <a:off x="2980944" y="658368"/>
+            <a:ext cx="3518490" cy="182880"/>
           </a:xfrm>
           <a:prstGeom prst="rect">
             <a:avLst/>
@@ -3644,8 +3644,8 @@
         </p:blipFill>
         <p:spPr>
           <a:xfrm>
-            <a:off x="4187952" y="850392"/>
-            <a:ext cx="3877056" cy="2442783"/>
+            <a:off x="2926080" y="850392"/>
+            <a:ext cx="3628218" cy="2286000"/>
           </a:xfrm>
           <a:prstGeom prst="rect">
             <a:avLst/>
@@ -3660,8 +3660,8 @@
         </p:nvSpPr>
         <p:spPr>
           <a:xfrm>
-            <a:off x="8174736" y="640080"/>
-            <a:ext cx="3877056" cy="201168"/>
+            <a:off x="6682314" y="640080"/>
+            <a:ext cx="4605130" cy="201168"/>
           </a:xfrm>
           <a:prstGeom prst="rect">
             <a:avLst/>
@@ -3703,8 +3703,8 @@
         </p:nvSpPr>
         <p:spPr>
           <a:xfrm>
-            <a:off x="8229600" y="658368"/>
-            <a:ext cx="3767328" cy="182880"/>
+            <a:off x="6737178" y="658368"/>
+            <a:ext cx="4495402" cy="182880"/>
           </a:xfrm>
           <a:prstGeom prst="rect">
             <a:avLst/>
@@ -3745,8 +3745,8 @@
         </p:blipFill>
         <p:spPr>
           <a:xfrm>
-            <a:off x="8174736" y="850392"/>
-            <a:ext cx="3877056" cy="1924581"/>
+            <a:off x="6682314" y="850392"/>
+            <a:ext cx="4605130" cy="2286000"/>
           </a:xfrm>
           <a:prstGeom prst="rect">
             <a:avLst/>
@@ -3761,8 +3761,8 @@
         </p:nvSpPr>
         <p:spPr>
           <a:xfrm>
-            <a:off x="4187952" y="3457767"/>
-            <a:ext cx="7863840" cy="201168"/>
+            <a:off x="2926080" y="3337560"/>
+            <a:ext cx="8017740" cy="201168"/>
           </a:xfrm>
           <a:prstGeom prst="rect">
             <a:avLst/>
@@ -3804,8 +3804,8 @@
         </p:nvSpPr>
         <p:spPr>
           <a:xfrm>
-            <a:off x="4242816" y="3476055"/>
-            <a:ext cx="7754112" cy="182880"/>
+            <a:off x="2980944" y="3355848"/>
+            <a:ext cx="7908012" cy="182880"/>
           </a:xfrm>
           <a:prstGeom prst="rect">
             <a:avLst/>
@@ -3846,8 +3846,8 @@
         </p:blipFill>
         <p:spPr>
           <a:xfrm>
-            <a:off x="4187952" y="3668079"/>
-            <a:ext cx="7863840" cy="3174842"/>
+            <a:off x="2926080" y="3547872"/>
+            <a:ext cx="8017740" cy="3236976"/>
           </a:xfrm>
           <a:prstGeom prst="rect">
             <a:avLst/>

</xml_diff>

<commit_message>
CF06: switch to text-only Shine presentation, add CF06 slides to main PPTX
Remove slide-based presentation (PPTX, build scripts, diagram PNGs, draft MD)
since the Shine AI evaluator reads text not slides. spoken_script.md is now
the sole presentation artifact. Add CF06 section (4 slides) to the main
codefest_presentation_bao_nguyen.pptx. Include CMAN diagram PNGs.

Co-Authored-By: Claude Sonnet 4.6 <noreply@anthropic.com>
</commit_message>
<xml_diff>
--- a/codefest/codefest_presentation_bao_nguyen.pptx
+++ b/codefest/codefest_presentation_bao_nguyen.pptx
@@ -6,6 +6,10 @@
   </p:sldMasterIdLst>
   <p:sldIdLst>
     <p:sldId id="256" r:id="rId7"/>
+    <p:sldId id="257" r:id="rId8"/>
+    <p:sldId id="258" r:id="rId9"/>
+    <p:sldId id="259" r:id="rId10"/>
+    <p:sldId id="260" r:id="rId11"/>
   </p:sldIdLst>
   <p:sldSz cx="12188952" cy="6858000" type="screen4x3"/>
   <p:notesSz cx="6858000" cy="9144000"/>
@@ -3854,6 +3858,2217 @@
           </a:prstGeom>
         </p:spPr>
       </p:pic>
+    </p:spTree>
+  </p:cSld>
+  <p:clrMapOvr>
+    <a:masterClrMapping/>
+  </p:clrMapOvr>
+</p:sld>
+</file>
+
+<file path=ppt/slides/slide2.xml><?xml version="1.0" encoding="utf-8"?>
+<p:sld xmlns:a="http://schemas.openxmlformats.org/drawingml/2006/main" xmlns:p="http://schemas.openxmlformats.org/presentationml/2006/main" xmlns:r="http://schemas.openxmlformats.org/officeDocument/2006/relationships">
+  <p:cSld>
+    <p:bg>
+      <p:bgPr>
+        <a:solidFill>
+          <a:srgbClr val="1E2229"/>
+        </a:solidFill>
+        <a:effectLst/>
+      </p:bgPr>
+    </p:bg>
+    <p:spTree>
+      <p:nvGrpSpPr>
+        <p:cNvPr id="1" name=""/>
+        <p:cNvGrpSpPr/>
+        <p:nvPr/>
+      </p:nvGrpSpPr>
+      <p:grpSpPr/>
+      <p:sp>
+        <p:nvSpPr>
+          <p:cNvPr id="2" name="Rectangle 1"/>
+          <p:cNvSpPr/>
+          <p:nvPr/>
+        </p:nvSpPr>
+        <p:spPr>
+          <a:xfrm>
+            <a:off x="0" y="0"/>
+            <a:ext cx="12188952" cy="82296"/>
+          </a:xfrm>
+          <a:prstGeom prst="rect">
+            <a:avLst/>
+          </a:prstGeom>
+          <a:solidFill>
+            <a:srgbClr val="008B8B"/>
+          </a:solidFill>
+          <a:ln>
+            <a:noFill/>
+          </a:ln>
+        </p:spPr>
+        <p:style>
+          <a:lnRef idx="1">
+            <a:schemeClr val="accent1"/>
+          </a:lnRef>
+          <a:fillRef idx="3">
+            <a:schemeClr val="accent1"/>
+          </a:fillRef>
+          <a:effectRef idx="2">
+            <a:schemeClr val="accent1"/>
+          </a:effectRef>
+          <a:fontRef idx="minor">
+            <a:schemeClr val="lt1"/>
+          </a:fontRef>
+        </p:style>
+        <p:txBody>
+          <a:bodyPr rtlCol="0" anchor="ctr"/>
+          <a:lstStyle/>
+          <a:p>
+            <a:pPr algn="ctr"/>
+          </a:p>
+        </p:txBody>
+      </p:sp>
+      <p:sp>
+        <p:nvSpPr>
+          <p:cNvPr id="3" name="Rectangle 2"/>
+          <p:cNvSpPr/>
+          <p:nvPr/>
+        </p:nvSpPr>
+        <p:spPr>
+          <a:xfrm>
+            <a:off x="0" y="2560320"/>
+            <a:ext cx="12188952" cy="1737360"/>
+          </a:xfrm>
+          <a:prstGeom prst="rect">
+            <a:avLst/>
+          </a:prstGeom>
+          <a:solidFill>
+            <a:srgbClr val="252C36"/>
+          </a:solidFill>
+          <a:ln>
+            <a:noFill/>
+          </a:ln>
+        </p:spPr>
+        <p:style>
+          <a:lnRef idx="1">
+            <a:schemeClr val="accent1"/>
+          </a:lnRef>
+          <a:fillRef idx="3">
+            <a:schemeClr val="accent1"/>
+          </a:fillRef>
+          <a:effectRef idx="2">
+            <a:schemeClr val="accent1"/>
+          </a:effectRef>
+          <a:fontRef idx="minor">
+            <a:schemeClr val="lt1"/>
+          </a:fontRef>
+        </p:style>
+        <p:txBody>
+          <a:bodyPr rtlCol="0" anchor="ctr"/>
+          <a:lstStyle/>
+          <a:p>
+            <a:pPr algn="ctr"/>
+          </a:p>
+        </p:txBody>
+      </p:sp>
+      <p:sp>
+        <p:nvSpPr>
+          <p:cNvPr id="4" name="TextBox 3"/>
+          <p:cNvSpPr txBox="1"/>
+          <p:nvPr/>
+        </p:nvSpPr>
+        <p:spPr>
+          <a:xfrm>
+            <a:off x="914400" y="2651760"/>
+            <a:ext cx="10332720" cy="731520"/>
+          </a:xfrm>
+          <a:prstGeom prst="rect">
+            <a:avLst/>
+          </a:prstGeom>
+          <a:noFill/>
+        </p:spPr>
+        <p:txBody>
+          <a:bodyPr wrap="square">
+            <a:spAutoFit/>
+          </a:bodyPr>
+          <a:lstStyle/>
+          <a:p>
+            <a:pPr algn="ctr"/>
+            <a:r>
+              <a:rPr sz="4000" b="1">
+                <a:solidFill>
+                  <a:srgbClr val="008B8B"/>
+                </a:solidFill>
+              </a:rPr>
+              <a:t>Codefest 6 — CLLM</a:t>
+            </a:r>
+          </a:p>
+        </p:txBody>
+      </p:sp>
+      <p:sp>
+        <p:nvSpPr>
+          <p:cNvPr id="5" name="TextBox 4"/>
+          <p:cNvSpPr txBox="1"/>
+          <p:nvPr/>
+        </p:nvSpPr>
+        <p:spPr>
+          <a:xfrm>
+            <a:off x="914400" y="3429000"/>
+            <a:ext cx="10332720" cy="594360"/>
+          </a:xfrm>
+          <a:prstGeom prst="rect">
+            <a:avLst/>
+          </a:prstGeom>
+          <a:noFill/>
+        </p:spPr>
+        <p:txBody>
+          <a:bodyPr wrap="square">
+            <a:spAutoFit/>
+          </a:bodyPr>
+          <a:lstStyle/>
+          <a:p>
+            <a:pPr algn="ctr"/>
+            <a:r>
+              <a:rPr sz="2400" b="0">
+                <a:solidFill>
+                  <a:srgbClr val="FFFFFF"/>
+                </a:solidFill>
+              </a:rPr>
+              <a:t>4×4 Binary-Weight Crossbar MAC Unit in SystemVerilog</a:t>
+            </a:r>
+          </a:p>
+        </p:txBody>
+      </p:sp>
+      <p:sp>
+        <p:nvSpPr>
+          <p:cNvPr id="6" name="TextBox 5"/>
+          <p:cNvSpPr txBox="1"/>
+          <p:nvPr/>
+        </p:nvSpPr>
+        <p:spPr>
+          <a:xfrm>
+            <a:off x="914400" y="4114800"/>
+            <a:ext cx="10332720" cy="457200"/>
+          </a:xfrm>
+          <a:prstGeom prst="rect">
+            <a:avLst/>
+          </a:prstGeom>
+          <a:noFill/>
+        </p:spPr>
+        <p:txBody>
+          <a:bodyPr wrap="square">
+            <a:spAutoFit/>
+          </a:bodyPr>
+          <a:lstStyle/>
+          <a:p>
+            <a:pPr algn="ctr"/>
+            <a:r>
+              <a:rPr sz="1600" b="0">
+                <a:solidFill>
+                  <a:srgbClr val="AAAAAA"/>
+                </a:solidFill>
+              </a:rPr>
+              <a:t>LLM: Claude Sonnet 4.6  ·  Tool: iverilog -g2012</a:t>
+            </a:r>
+          </a:p>
+        </p:txBody>
+      </p:sp>
+    </p:spTree>
+  </p:cSld>
+  <p:clrMapOvr>
+    <a:masterClrMapping/>
+  </p:clrMapOvr>
+</p:sld>
+</file>
+
+<file path=ppt/slides/slide3.xml><?xml version="1.0" encoding="utf-8"?>
+<p:sld xmlns:a="http://schemas.openxmlformats.org/drawingml/2006/main" xmlns:p="http://schemas.openxmlformats.org/presentationml/2006/main" xmlns:r="http://schemas.openxmlformats.org/officeDocument/2006/relationships">
+  <p:cSld>
+    <p:bg>
+      <p:bgPr>
+        <a:solidFill>
+          <a:srgbClr val="F2F4F6"/>
+        </a:solidFill>
+        <a:effectLst/>
+      </p:bgPr>
+    </p:bg>
+    <p:spTree>
+      <p:nvGrpSpPr>
+        <p:cNvPr id="1" name=""/>
+        <p:cNvGrpSpPr/>
+        <p:nvPr/>
+      </p:nvGrpSpPr>
+      <p:grpSpPr/>
+      <p:sp>
+        <p:nvSpPr>
+          <p:cNvPr id="2" name="Rectangle 1"/>
+          <p:cNvSpPr/>
+          <p:nvPr/>
+        </p:nvSpPr>
+        <p:spPr>
+          <a:xfrm>
+            <a:off x="0" y="0"/>
+            <a:ext cx="12188952" cy="82296"/>
+          </a:xfrm>
+          <a:prstGeom prst="rect">
+            <a:avLst/>
+          </a:prstGeom>
+          <a:solidFill>
+            <a:srgbClr val="008B8B"/>
+          </a:solidFill>
+          <a:ln>
+            <a:noFill/>
+          </a:ln>
+        </p:spPr>
+        <p:style>
+          <a:lnRef idx="1">
+            <a:schemeClr val="accent1"/>
+          </a:lnRef>
+          <a:fillRef idx="3">
+            <a:schemeClr val="accent1"/>
+          </a:fillRef>
+          <a:effectRef idx="2">
+            <a:schemeClr val="accent1"/>
+          </a:effectRef>
+          <a:fontRef idx="minor">
+            <a:schemeClr val="lt1"/>
+          </a:fontRef>
+        </p:style>
+        <p:txBody>
+          <a:bodyPr rtlCol="0" anchor="ctr"/>
+          <a:lstStyle/>
+          <a:p>
+            <a:pPr algn="ctr"/>
+          </a:p>
+        </p:txBody>
+      </p:sp>
+      <p:sp>
+        <p:nvSpPr>
+          <p:cNvPr id="3" name="TextBox 2"/>
+          <p:cNvSpPr txBox="1"/>
+          <p:nvPr/>
+        </p:nvSpPr>
+        <p:spPr>
+          <a:xfrm>
+            <a:off x="457200" y="137160"/>
+            <a:ext cx="8229600" cy="548640"/>
+          </a:xfrm>
+          <a:prstGeom prst="rect">
+            <a:avLst/>
+          </a:prstGeom>
+          <a:noFill/>
+        </p:spPr>
+        <p:txBody>
+          <a:bodyPr wrap="square">
+            <a:spAutoFit/>
+          </a:bodyPr>
+          <a:lstStyle/>
+          <a:p>
+            <a:pPr algn="l"/>
+            <a:r>
+              <a:rPr sz="3000" b="1">
+                <a:solidFill>
+                  <a:srgbClr val="2C3E50"/>
+                </a:solidFill>
+              </a:rPr>
+              <a:t>The Design</a:t>
+            </a:r>
+          </a:p>
+        </p:txBody>
+      </p:sp>
+      <p:pic>
+        <p:nvPicPr>
+          <p:cNvPr id="4" name="Picture 3" descr="slide_crossbar.png"/>
+          <p:cNvPicPr>
+            <a:picLocks noChangeAspect="1"/>
+          </p:cNvPicPr>
+          <p:nvPr/>
+        </p:nvPicPr>
+        <p:blipFill>
+          <a:blip r:embed="rId2"/>
+          <a:stretch>
+            <a:fillRect/>
+          </a:stretch>
+        </p:blipFill>
+        <p:spPr>
+          <a:xfrm>
+            <a:off x="274320" y="777240"/>
+            <a:ext cx="5943600" cy="5303520"/>
+          </a:xfrm>
+          <a:prstGeom prst="rect">
+            <a:avLst/>
+          </a:prstGeom>
+        </p:spPr>
+      </p:pic>
+      <p:sp>
+        <p:nvSpPr>
+          <p:cNvPr id="5" name="Rectangle 4"/>
+          <p:cNvSpPr/>
+          <p:nvPr/>
+        </p:nvSpPr>
+        <p:spPr>
+          <a:xfrm>
+            <a:off x="6400800" y="777240"/>
+            <a:ext cx="5577840" cy="5303520"/>
+          </a:xfrm>
+          <a:prstGeom prst="rect">
+            <a:avLst/>
+          </a:prstGeom>
+          <a:solidFill>
+            <a:srgbClr val="FFFFFF"/>
+          </a:solidFill>
+          <a:ln w="19050">
+            <a:solidFill>
+              <a:srgbClr val="008B8B"/>
+            </a:solidFill>
+          </a:ln>
+        </p:spPr>
+        <p:style>
+          <a:lnRef idx="1">
+            <a:schemeClr val="accent1"/>
+          </a:lnRef>
+          <a:fillRef idx="3">
+            <a:schemeClr val="accent1"/>
+          </a:fillRef>
+          <a:effectRef idx="2">
+            <a:schemeClr val="accent1"/>
+          </a:effectRef>
+          <a:fontRef idx="minor">
+            <a:schemeClr val="lt1"/>
+          </a:fontRef>
+        </p:style>
+        <p:txBody>
+          <a:bodyPr rtlCol="0" anchor="ctr"/>
+          <a:lstStyle/>
+          <a:p>
+            <a:pPr algn="ctr"/>
+          </a:p>
+        </p:txBody>
+      </p:sp>
+      <p:sp>
+        <p:nvSpPr>
+          <p:cNvPr id="6" name="TextBox 5"/>
+          <p:cNvSpPr txBox="1"/>
+          <p:nvPr/>
+        </p:nvSpPr>
+        <p:spPr>
+          <a:xfrm>
+            <a:off x="6537960" y="960120"/>
+            <a:ext cx="5257800" cy="365760"/>
+          </a:xfrm>
+          <a:prstGeom prst="rect">
+            <a:avLst/>
+          </a:prstGeom>
+          <a:noFill/>
+        </p:spPr>
+        <p:txBody>
+          <a:bodyPr wrap="square">
+            <a:spAutoFit/>
+          </a:bodyPr>
+          <a:lstStyle/>
+          <a:p>
+            <a:pPr algn="l"/>
+            <a:r>
+              <a:rPr sz="1700" b="1">
+                <a:solidFill>
+                  <a:srgbClr val="008B8B"/>
+                </a:solidFill>
+              </a:rPr>
+              <a:t>out[j] = Σᵢ weight[i][j] × in[i]</a:t>
+            </a:r>
+          </a:p>
+        </p:txBody>
+      </p:sp>
+      <p:sp>
+        <p:nvSpPr>
+          <p:cNvPr id="7" name="TextBox 6"/>
+          <p:cNvSpPr txBox="1"/>
+          <p:nvPr/>
+        </p:nvSpPr>
+        <p:spPr>
+          <a:xfrm>
+            <a:off x="6537960" y="1327149"/>
+            <a:ext cx="5257800" cy="365760"/>
+          </a:xfrm>
+          <a:prstGeom prst="rect">
+            <a:avLst/>
+          </a:prstGeom>
+          <a:noFill/>
+        </p:spPr>
+        <p:txBody>
+          <a:bodyPr wrap="square">
+            <a:spAutoFit/>
+          </a:bodyPr>
+          <a:lstStyle/>
+          <a:p>
+            <a:pPr algn="l"/>
+            <a:r>
+              <a:rPr sz="800" b="0">
+                <a:solidFill>
+                  <a:srgbClr val="2C3E50"/>
+                </a:solidFill>
+              </a:rPr>
+              <a:t/>
+            </a:r>
+          </a:p>
+        </p:txBody>
+      </p:sp>
+      <p:sp>
+        <p:nvSpPr>
+          <p:cNvPr id="8" name="TextBox 7"/>
+          <p:cNvSpPr txBox="1"/>
+          <p:nvPr/>
+        </p:nvSpPr>
+        <p:spPr>
+          <a:xfrm>
+            <a:off x="6537960" y="1499869"/>
+            <a:ext cx="5257800" cy="365760"/>
+          </a:xfrm>
+          <a:prstGeom prst="rect">
+            <a:avLst/>
+          </a:prstGeom>
+          <a:noFill/>
+        </p:spPr>
+        <p:txBody>
+          <a:bodyPr wrap="square">
+            <a:spAutoFit/>
+          </a:bodyPr>
+          <a:lstStyle/>
+          <a:p>
+            <a:pPr algn="l"/>
+            <a:r>
+              <a:rPr sz="1700" b="1">
+                <a:solidFill>
+                  <a:srgbClr val="2C3E50"/>
+                </a:solidFill>
+              </a:rPr>
+              <a:t>3-stage pipeline:</a:t>
+            </a:r>
+          </a:p>
+        </p:txBody>
+      </p:sp>
+      <p:sp>
+        <p:nvSpPr>
+          <p:cNvPr id="9" name="TextBox 8"/>
+          <p:cNvSpPr txBox="1"/>
+          <p:nvPr/>
+        </p:nvSpPr>
+        <p:spPr>
+          <a:xfrm>
+            <a:off x="6537960" y="1866898"/>
+            <a:ext cx="5257800" cy="365760"/>
+          </a:xfrm>
+          <a:prstGeom prst="rect">
+            <a:avLst/>
+          </a:prstGeom>
+          <a:noFill/>
+        </p:spPr>
+        <p:txBody>
+          <a:bodyPr wrap="square">
+            <a:spAutoFit/>
+          </a:bodyPr>
+          <a:lstStyle/>
+          <a:p>
+            <a:pPr algn="l"/>
+            <a:r>
+              <a:rPr sz="1500" b="0">
+                <a:solidFill>
+                  <a:srgbClr val="8E44AD"/>
+                </a:solidFill>
+              </a:rPr>
+              <a:t>① Weight register  (16-bit flat, 1 cycle load)</a:t>
+            </a:r>
+          </a:p>
+        </p:txBody>
+      </p:sp>
+      <p:sp>
+        <p:nvSpPr>
+          <p:cNvPr id="10" name="TextBox 9"/>
+          <p:cNvSpPr txBox="1"/>
+          <p:nvPr/>
+        </p:nvSpPr>
+        <p:spPr>
+          <a:xfrm>
+            <a:off x="6537960" y="2190748"/>
+            <a:ext cx="5257800" cy="365760"/>
+          </a:xfrm>
+          <a:prstGeom prst="rect">
+            <a:avLst/>
+          </a:prstGeom>
+          <a:noFill/>
+        </p:spPr>
+        <p:txBody>
+          <a:bodyPr wrap="square">
+            <a:spAutoFit/>
+          </a:bodyPr>
+          <a:lstStyle/>
+          <a:p>
+            <a:pPr algn="l"/>
+            <a:r>
+              <a:rPr sz="1500" b="0">
+                <a:solidFill>
+                  <a:srgbClr val="E67E22"/>
+                </a:solidFill>
+              </a:rPr>
+              <a:t>② Combinational MAC  (all 4 outputs parallel)</a:t>
+            </a:r>
+          </a:p>
+        </p:txBody>
+      </p:sp>
+      <p:sp>
+        <p:nvSpPr>
+          <p:cNvPr id="11" name="TextBox 10"/>
+          <p:cNvSpPr txBox="1"/>
+          <p:nvPr/>
+        </p:nvSpPr>
+        <p:spPr>
+          <a:xfrm>
+            <a:off x="6537960" y="2514598"/>
+            <a:ext cx="5257800" cy="365760"/>
+          </a:xfrm>
+          <a:prstGeom prst="rect">
+            <a:avLst/>
+          </a:prstGeom>
+          <a:noFill/>
+        </p:spPr>
+        <p:txBody>
+          <a:bodyPr wrap="square">
+            <a:spAutoFit/>
+          </a:bodyPr>
+          <a:lstStyle/>
+          <a:p>
+            <a:pPr algn="l"/>
+            <a:r>
+              <a:rPr sz="1500" b="0">
+                <a:solidFill>
+                  <a:srgbClr val="27AE60"/>
+                </a:solidFill>
+              </a:rPr>
+              <a:t>③ Output register  (10-bit signed)</a:t>
+            </a:r>
+          </a:p>
+        </p:txBody>
+      </p:sp>
+      <p:sp>
+        <p:nvSpPr>
+          <p:cNvPr id="12" name="TextBox 11"/>
+          <p:cNvSpPr txBox="1"/>
+          <p:nvPr/>
+        </p:nvSpPr>
+        <p:spPr>
+          <a:xfrm>
+            <a:off x="6537960" y="2838448"/>
+            <a:ext cx="5257800" cy="365760"/>
+          </a:xfrm>
+          <a:prstGeom prst="rect">
+            <a:avLst/>
+          </a:prstGeom>
+          <a:noFill/>
+        </p:spPr>
+        <p:txBody>
+          <a:bodyPr wrap="square">
+            <a:spAutoFit/>
+          </a:bodyPr>
+          <a:lstStyle/>
+          <a:p>
+            <a:pPr algn="l"/>
+            <a:r>
+              <a:rPr sz="800" b="0">
+                <a:solidFill>
+                  <a:srgbClr val="2C3E50"/>
+                </a:solidFill>
+              </a:rPr>
+              <a:t/>
+            </a:r>
+          </a:p>
+        </p:txBody>
+      </p:sp>
+      <p:sp>
+        <p:nvSpPr>
+          <p:cNvPr id="13" name="TextBox 12"/>
+          <p:cNvSpPr txBox="1"/>
+          <p:nvPr/>
+        </p:nvSpPr>
+        <p:spPr>
+          <a:xfrm>
+            <a:off x="6537960" y="3011168"/>
+            <a:ext cx="5257800" cy="365760"/>
+          </a:xfrm>
+          <a:prstGeom prst="rect">
+            <a:avLst/>
+          </a:prstGeom>
+          <a:noFill/>
+        </p:spPr>
+        <p:txBody>
+          <a:bodyPr wrap="square">
+            <a:spAutoFit/>
+          </a:bodyPr>
+          <a:lstStyle/>
+          <a:p>
+            <a:pPr algn="l"/>
+            <a:r>
+              <a:rPr sz="1700" b="1">
+                <a:solidFill>
+                  <a:srgbClr val="2C3E50"/>
+                </a:solidFill>
+              </a:rPr>
+              <a:t>Key choices:</a:t>
+            </a:r>
+          </a:p>
+        </p:txBody>
+      </p:sp>
+      <p:sp>
+        <p:nvSpPr>
+          <p:cNvPr id="14" name="TextBox 13"/>
+          <p:cNvSpPr txBox="1"/>
+          <p:nvPr/>
+        </p:nvSpPr>
+        <p:spPr>
+          <a:xfrm>
+            <a:off x="6537960" y="3378197"/>
+            <a:ext cx="5257800" cy="365760"/>
+          </a:xfrm>
+          <a:prstGeom prst="rect">
+            <a:avLst/>
+          </a:prstGeom>
+          <a:noFill/>
+        </p:spPr>
+        <p:txBody>
+          <a:bodyPr wrap="square">
+            <a:spAutoFit/>
+          </a:bodyPr>
+          <a:lstStyle/>
+          <a:p>
+            <a:pPr algn="l"/>
+            <a:r>
+              <a:rPr sz="1400" b="0">
+                <a:solidFill>
+                  <a:srgbClr val="2C3E50"/>
+                </a:solidFill>
+              </a:rPr>
+              <a:t>Flat 16-bit reg → load full matrix in 1 cycle</a:t>
+            </a:r>
+          </a:p>
+        </p:txBody>
+      </p:sp>
+      <p:sp>
+        <p:nvSpPr>
+          <p:cNvPr id="15" name="TextBox 14"/>
+          <p:cNvSpPr txBox="1"/>
+          <p:nvPr/>
+        </p:nvSpPr>
+        <p:spPr>
+          <a:xfrm>
+            <a:off x="6537960" y="3680457"/>
+            <a:ext cx="5257800" cy="365760"/>
+          </a:xfrm>
+          <a:prstGeom prst="rect">
+            <a:avLst/>
+          </a:prstGeom>
+          <a:noFill/>
+        </p:spPr>
+        <p:txBody>
+          <a:bodyPr wrap="square">
+            <a:spAutoFit/>
+          </a:bodyPr>
+          <a:lstStyle/>
+          <a:p>
+            <a:pPr algn="l"/>
+            <a:r>
+              <a:rPr sz="1400" b="0">
+                <a:solidFill>
+                  <a:srgbClr val="2C3E50"/>
+                </a:solidFill>
+              </a:rPr>
+              <a:t>Scalar ports → iverilog compatibility</a:t>
+            </a:r>
+          </a:p>
+        </p:txBody>
+      </p:sp>
+      <p:sp>
+        <p:nvSpPr>
+          <p:cNvPr id="16" name="TextBox 15"/>
+          <p:cNvSpPr txBox="1"/>
+          <p:nvPr/>
+        </p:nvSpPr>
+        <p:spPr>
+          <a:xfrm>
+            <a:off x="6537960" y="3982717"/>
+            <a:ext cx="5257800" cy="365760"/>
+          </a:xfrm>
+          <a:prstGeom prst="rect">
+            <a:avLst/>
+          </a:prstGeom>
+          <a:noFill/>
+        </p:spPr>
+        <p:txBody>
+          <a:bodyPr wrap="square">
+            <a:spAutoFit/>
+          </a:bodyPr>
+          <a:lstStyle/>
+          <a:p>
+            <a:pPr algn="l"/>
+            <a:r>
+              <a:rPr sz="1400" b="0">
+                <a:solidFill>
+                  <a:srgbClr val="2C3E50"/>
+                </a:solidFill>
+              </a:rPr>
+              <a:t>10-bit out → 4×127=508 fits in 511 max</a:t>
+            </a:r>
+          </a:p>
+        </p:txBody>
+      </p:sp>
+    </p:spTree>
+  </p:cSld>
+  <p:clrMapOvr>
+    <a:masterClrMapping/>
+  </p:clrMapOvr>
+</p:sld>
+</file>
+
+<file path=ppt/slides/slide4.xml><?xml version="1.0" encoding="utf-8"?>
+<p:sld xmlns:a="http://schemas.openxmlformats.org/drawingml/2006/main" xmlns:p="http://schemas.openxmlformats.org/presentationml/2006/main" xmlns:r="http://schemas.openxmlformats.org/officeDocument/2006/relationships">
+  <p:cSld>
+    <p:bg>
+      <p:bgPr>
+        <a:solidFill>
+          <a:srgbClr val="F2F4F6"/>
+        </a:solidFill>
+        <a:effectLst/>
+      </p:bgPr>
+    </p:bg>
+    <p:spTree>
+      <p:nvGrpSpPr>
+        <p:cNvPr id="1" name=""/>
+        <p:cNvGrpSpPr/>
+        <p:nvPr/>
+      </p:nvGrpSpPr>
+      <p:grpSpPr/>
+      <p:sp>
+        <p:nvSpPr>
+          <p:cNvPr id="2" name="Rectangle 1"/>
+          <p:cNvSpPr/>
+          <p:nvPr/>
+        </p:nvSpPr>
+        <p:spPr>
+          <a:xfrm>
+            <a:off x="0" y="0"/>
+            <a:ext cx="12188952" cy="82296"/>
+          </a:xfrm>
+          <a:prstGeom prst="rect">
+            <a:avLst/>
+          </a:prstGeom>
+          <a:solidFill>
+            <a:srgbClr val="008B8B"/>
+          </a:solidFill>
+          <a:ln>
+            <a:noFill/>
+          </a:ln>
+        </p:spPr>
+        <p:style>
+          <a:lnRef idx="1">
+            <a:schemeClr val="accent1"/>
+          </a:lnRef>
+          <a:fillRef idx="3">
+            <a:schemeClr val="accent1"/>
+          </a:fillRef>
+          <a:effectRef idx="2">
+            <a:schemeClr val="accent1"/>
+          </a:effectRef>
+          <a:fontRef idx="minor">
+            <a:schemeClr val="lt1"/>
+          </a:fontRef>
+        </p:style>
+        <p:txBody>
+          <a:bodyPr rtlCol="0" anchor="ctr"/>
+          <a:lstStyle/>
+          <a:p>
+            <a:pPr algn="ctr"/>
+          </a:p>
+        </p:txBody>
+      </p:sp>
+      <p:sp>
+        <p:nvSpPr>
+          <p:cNvPr id="3" name="TextBox 2"/>
+          <p:cNvSpPr txBox="1"/>
+          <p:nvPr/>
+        </p:nvSpPr>
+        <p:spPr>
+          <a:xfrm>
+            <a:off x="457200" y="137160"/>
+            <a:ext cx="8229600" cy="548640"/>
+          </a:xfrm>
+          <a:prstGeom prst="rect">
+            <a:avLst/>
+          </a:prstGeom>
+          <a:noFill/>
+        </p:spPr>
+        <p:txBody>
+          <a:bodyPr wrap="square">
+            <a:spAutoFit/>
+          </a:bodyPr>
+          <a:lstStyle/>
+          <a:p>
+            <a:pPr algn="l"/>
+            <a:r>
+              <a:rPr sz="3000" b="1">
+                <a:solidFill>
+                  <a:srgbClr val="2C3E50"/>
+                </a:solidFill>
+              </a:rPr>
+              <a:t>The Testbench</a:t>
+            </a:r>
+          </a:p>
+        </p:txBody>
+      </p:sp>
+      <p:pic>
+        <p:nvPicPr>
+          <p:cNvPr id="4" name="Picture 3" descr="slide_timing.png"/>
+          <p:cNvPicPr>
+            <a:picLocks noChangeAspect="1"/>
+          </p:cNvPicPr>
+          <p:nvPr/>
+        </p:nvPicPr>
+        <p:blipFill>
+          <a:blip r:embed="rId2"/>
+          <a:stretch>
+            <a:fillRect/>
+          </a:stretch>
+        </p:blipFill>
+        <p:spPr>
+          <a:xfrm>
+            <a:off x="274320" y="777240"/>
+            <a:ext cx="7315200" cy="3840480"/>
+          </a:xfrm>
+          <a:prstGeom prst="rect">
+            <a:avLst/>
+          </a:prstGeom>
+        </p:spPr>
+      </p:pic>
+      <p:sp>
+        <p:nvSpPr>
+          <p:cNvPr id="5" name="Rectangle 4"/>
+          <p:cNvSpPr/>
+          <p:nvPr/>
+        </p:nvSpPr>
+        <p:spPr>
+          <a:xfrm>
+            <a:off x="274320" y="4709160"/>
+            <a:ext cx="7223760" cy="1828800"/>
+          </a:xfrm>
+          <a:prstGeom prst="rect">
+            <a:avLst/>
+          </a:prstGeom>
+          <a:solidFill>
+            <a:srgbClr val="FFFFFF"/>
+          </a:solidFill>
+          <a:ln w="19050">
+            <a:solidFill>
+              <a:srgbClr val="008B8B"/>
+            </a:solidFill>
+          </a:ln>
+        </p:spPr>
+        <p:style>
+          <a:lnRef idx="1">
+            <a:schemeClr val="accent1"/>
+          </a:lnRef>
+          <a:fillRef idx="3">
+            <a:schemeClr val="accent1"/>
+          </a:fillRef>
+          <a:effectRef idx="2">
+            <a:schemeClr val="accent1"/>
+          </a:effectRef>
+          <a:fontRef idx="minor">
+            <a:schemeClr val="lt1"/>
+          </a:fontRef>
+        </p:style>
+        <p:txBody>
+          <a:bodyPr rtlCol="0" anchor="ctr"/>
+          <a:lstStyle/>
+          <a:p>
+            <a:pPr algn="ctr"/>
+          </a:p>
+        </p:txBody>
+      </p:sp>
+      <p:sp>
+        <p:nvSpPr>
+          <p:cNvPr id="6" name="TextBox 5"/>
+          <p:cNvSpPr txBox="1"/>
+          <p:nvPr/>
+        </p:nvSpPr>
+        <p:spPr>
+          <a:xfrm>
+            <a:off x="457200" y="4773168"/>
+            <a:ext cx="6858000" cy="411480"/>
+          </a:xfrm>
+          <a:prstGeom prst="rect">
+            <a:avLst/>
+          </a:prstGeom>
+          <a:noFill/>
+        </p:spPr>
+        <p:txBody>
+          <a:bodyPr wrap="square">
+            <a:spAutoFit/>
+          </a:bodyPr>
+          <a:lstStyle/>
+          <a:p>
+            <a:pPr algn="l"/>
+            <a:r>
+              <a:rPr sz="1400" b="0">
+                <a:solidFill>
+                  <a:srgbClr val="2C3E50"/>
+                </a:solidFill>
+              </a:rPr>
+              <a:t>Weights loaded:  [[+1,-1,+1,-1], [+1,+1,-1,-1], [-1,+1,+1,-1], [-1,-1,-1,+1]]</a:t>
+            </a:r>
+          </a:p>
+        </p:txBody>
+      </p:sp>
+      <p:sp>
+        <p:nvSpPr>
+          <p:cNvPr id="7" name="TextBox 6"/>
+          <p:cNvSpPr txBox="1"/>
+          <p:nvPr/>
+        </p:nvSpPr>
+        <p:spPr>
+          <a:xfrm>
+            <a:off x="457200" y="5166360"/>
+            <a:ext cx="6858000" cy="365760"/>
+          </a:xfrm>
+          <a:prstGeom prst="rect">
+            <a:avLst/>
+          </a:prstGeom>
+          <a:noFill/>
+        </p:spPr>
+        <p:txBody>
+          <a:bodyPr wrap="square">
+            <a:spAutoFit/>
+          </a:bodyPr>
+          <a:lstStyle/>
+          <a:p>
+            <a:pPr algn="l"/>
+            <a:r>
+              <a:rPr sz="1400" b="0">
+                <a:solidFill>
+                  <a:srgbClr val="2C3E50"/>
+                </a:solidFill>
+              </a:rPr>
+              <a:t>Inputs:  in = [10, 20, 30, 40]</a:t>
+            </a:r>
+          </a:p>
+        </p:txBody>
+      </p:sp>
+      <p:sp>
+        <p:nvSpPr>
+          <p:cNvPr id="8" name="TextBox 7"/>
+          <p:cNvSpPr txBox="1"/>
+          <p:nvPr/>
+        </p:nvSpPr>
+        <p:spPr>
+          <a:xfrm>
+            <a:off x="457200" y="5532120"/>
+            <a:ext cx="6858000" cy="365760"/>
+          </a:xfrm>
+          <a:prstGeom prst="rect">
+            <a:avLst/>
+          </a:prstGeom>
+          <a:noFill/>
+        </p:spPr>
+        <p:txBody>
+          <a:bodyPr wrap="square">
+            <a:spAutoFit/>
+          </a:bodyPr>
+          <a:lstStyle/>
+          <a:p>
+            <a:pPr algn="l"/>
+            <a:r>
+              <a:rPr sz="1400" b="1">
+                <a:solidFill>
+                  <a:srgbClr val="3498DB"/>
+                </a:solidFill>
+              </a:rPr>
+              <a:t>Hand-calc before running:  out = [−40, 0, −20, −20]</a:t>
+            </a:r>
+          </a:p>
+        </p:txBody>
+      </p:sp>
+      <p:sp>
+        <p:nvSpPr>
+          <p:cNvPr id="9" name="TextBox 8"/>
+          <p:cNvSpPr txBox="1"/>
+          <p:nvPr/>
+        </p:nvSpPr>
+        <p:spPr>
+          <a:xfrm>
+            <a:off x="457200" y="5943600"/>
+            <a:ext cx="6858000" cy="411480"/>
+          </a:xfrm>
+          <a:prstGeom prst="rect">
+            <a:avLst/>
+          </a:prstGeom>
+          <a:noFill/>
+        </p:spPr>
+        <p:txBody>
+          <a:bodyPr wrap="square">
+            <a:spAutoFit/>
+          </a:bodyPr>
+          <a:lstStyle/>
+          <a:p>
+            <a:pPr algn="l"/>
+            <a:r>
+              <a:rPr sz="1300" b="0">
+                <a:solidFill>
+                  <a:srgbClr val="E67E22"/>
+                </a:solidFill>
+              </a:rPr>
+              <a:t>Key: wait 2 cycles after weight_load — output register clocks on same edge as weight register</a:t>
+            </a:r>
+          </a:p>
+        </p:txBody>
+      </p:sp>
+      <p:sp>
+        <p:nvSpPr>
+          <p:cNvPr id="10" name="Rectangle 9"/>
+          <p:cNvSpPr/>
+          <p:nvPr/>
+        </p:nvSpPr>
+        <p:spPr>
+          <a:xfrm>
+            <a:off x="7726679" y="777240"/>
+            <a:ext cx="4343400" cy="5760720"/>
+          </a:xfrm>
+          <a:prstGeom prst="rect">
+            <a:avLst/>
+          </a:prstGeom>
+          <a:solidFill>
+            <a:srgbClr val="FFFFFF"/>
+          </a:solidFill>
+          <a:ln w="19050">
+            <a:solidFill>
+              <a:srgbClr val="008B8B"/>
+            </a:solidFill>
+          </a:ln>
+        </p:spPr>
+        <p:style>
+          <a:lnRef idx="1">
+            <a:schemeClr val="accent1"/>
+          </a:lnRef>
+          <a:fillRef idx="3">
+            <a:schemeClr val="accent1"/>
+          </a:fillRef>
+          <a:effectRef idx="2">
+            <a:schemeClr val="accent1"/>
+          </a:effectRef>
+          <a:fontRef idx="minor">
+            <a:schemeClr val="lt1"/>
+          </a:fontRef>
+        </p:style>
+        <p:txBody>
+          <a:bodyPr rtlCol="0" anchor="ctr"/>
+          <a:lstStyle/>
+          <a:p>
+            <a:pPr algn="ctr"/>
+          </a:p>
+        </p:txBody>
+      </p:sp>
+      <p:sp>
+        <p:nvSpPr>
+          <p:cNvPr id="11" name="TextBox 10"/>
+          <p:cNvSpPr txBox="1"/>
+          <p:nvPr/>
+        </p:nvSpPr>
+        <p:spPr>
+          <a:xfrm>
+            <a:off x="7863840" y="960120"/>
+            <a:ext cx="4023360" cy="347472"/>
+          </a:xfrm>
+          <a:prstGeom prst="rect">
+            <a:avLst/>
+          </a:prstGeom>
+          <a:noFill/>
+        </p:spPr>
+        <p:txBody>
+          <a:bodyPr wrap="square">
+            <a:spAutoFit/>
+          </a:bodyPr>
+          <a:lstStyle/>
+          <a:p>
+            <a:pPr algn="l"/>
+            <a:r>
+              <a:rPr sz="1700" b="1">
+                <a:solidFill>
+                  <a:srgbClr val="008B8B"/>
+                </a:solidFill>
+              </a:rPr>
+              <a:t>Why 2 cycles?</a:t>
+            </a:r>
+          </a:p>
+        </p:txBody>
+      </p:sp>
+      <p:sp>
+        <p:nvSpPr>
+          <p:cNvPr id="12" name="TextBox 11"/>
+          <p:cNvSpPr txBox="1"/>
+          <p:nvPr/>
+        </p:nvSpPr>
+        <p:spPr>
+          <a:xfrm>
+            <a:off x="7863840" y="1348740"/>
+            <a:ext cx="4023360" cy="347472"/>
+          </a:xfrm>
+          <a:prstGeom prst="rect">
+            <a:avLst/>
+          </a:prstGeom>
+          <a:noFill/>
+        </p:spPr>
+        <p:txBody>
+          <a:bodyPr wrap="square">
+            <a:spAutoFit/>
+          </a:bodyPr>
+          <a:lstStyle/>
+          <a:p>
+            <a:pPr algn="l"/>
+            <a:r>
+              <a:rPr sz="800" b="0">
+                <a:solidFill>
+                  <a:srgbClr val="2C3E50"/>
+                </a:solidFill>
+              </a:rPr>
+              <a:t/>
+            </a:r>
+          </a:p>
+        </p:txBody>
+      </p:sp>
+      <p:sp>
+        <p:nvSpPr>
+          <p:cNvPr id="13" name="TextBox 12"/>
+          <p:cNvSpPr txBox="1"/>
+          <p:nvPr/>
+        </p:nvSpPr>
+        <p:spPr>
+          <a:xfrm>
+            <a:off x="7863840" y="1531619"/>
+            <a:ext cx="4023360" cy="347472"/>
+          </a:xfrm>
+          <a:prstGeom prst="rect">
+            <a:avLst/>
+          </a:prstGeom>
+          <a:noFill/>
+        </p:spPr>
+        <p:txBody>
+          <a:bodyPr wrap="square">
+            <a:spAutoFit/>
+          </a:bodyPr>
+          <a:lstStyle/>
+          <a:p>
+            <a:pPr algn="l"/>
+            <a:r>
+              <a:rPr sz="1400" b="1">
+                <a:solidFill>
+                  <a:srgbClr val="2C3E50"/>
+                </a:solidFill>
+              </a:rPr>
+              <a:t>Cycle 1 (weight_load=1):</a:t>
+            </a:r>
+          </a:p>
+        </p:txBody>
+      </p:sp>
+      <p:sp>
+        <p:nvSpPr>
+          <p:cNvPr id="14" name="TextBox 13"/>
+          <p:cNvSpPr txBox="1"/>
+          <p:nvPr/>
+        </p:nvSpPr>
+        <p:spPr>
+          <a:xfrm>
+            <a:off x="7863840" y="1851659"/>
+            <a:ext cx="4023360" cy="347472"/>
+          </a:xfrm>
+          <a:prstGeom prst="rect">
+            <a:avLst/>
+          </a:prstGeom>
+          <a:noFill/>
+        </p:spPr>
+        <p:txBody>
+          <a:bodyPr wrap="square">
+            <a:spAutoFit/>
+          </a:bodyPr>
+          <a:lstStyle/>
+          <a:p>
+            <a:pPr algn="l"/>
+            <a:r>
+              <a:rPr sz="1300" b="0">
+                <a:solidFill>
+                  <a:srgbClr val="8E44AD"/>
+                </a:solidFill>
+              </a:rPr>
+              <a:t>wreg ← weight_in</a:t>
+            </a:r>
+          </a:p>
+        </p:txBody>
+      </p:sp>
+      <p:sp>
+        <p:nvSpPr>
+          <p:cNvPr id="15" name="TextBox 14"/>
+          <p:cNvSpPr txBox="1"/>
+          <p:nvPr/>
+        </p:nvSpPr>
+        <p:spPr>
+          <a:xfrm>
+            <a:off x="7863840" y="2148839"/>
+            <a:ext cx="4023360" cy="347472"/>
+          </a:xfrm>
+          <a:prstGeom prst="rect">
+            <a:avLst/>
+          </a:prstGeom>
+          <a:noFill/>
+        </p:spPr>
+        <p:txBody>
+          <a:bodyPr wrap="square">
+            <a:spAutoFit/>
+          </a:bodyPr>
+          <a:lstStyle/>
+          <a:p>
+            <a:pPr algn="l"/>
+            <a:r>
+              <a:rPr sz="1300" b="0">
+                <a:solidFill>
+                  <a:srgbClr val="E74C3C"/>
+                </a:solidFill>
+              </a:rPr>
+              <a:t>out ← MAC(old wreg) ✗</a:t>
+            </a:r>
+          </a:p>
+        </p:txBody>
+      </p:sp>
+      <p:sp>
+        <p:nvSpPr>
+          <p:cNvPr id="16" name="TextBox 15"/>
+          <p:cNvSpPr txBox="1"/>
+          <p:nvPr/>
+        </p:nvSpPr>
+        <p:spPr>
+          <a:xfrm>
+            <a:off x="7863840" y="2446019"/>
+            <a:ext cx="4023360" cy="347472"/>
+          </a:xfrm>
+          <a:prstGeom prst="rect">
+            <a:avLst/>
+          </a:prstGeom>
+          <a:noFill/>
+        </p:spPr>
+        <p:txBody>
+          <a:bodyPr wrap="square">
+            <a:spAutoFit/>
+          </a:bodyPr>
+          <a:lstStyle/>
+          <a:p>
+            <a:pPr algn="l"/>
+            <a:r>
+              <a:rPr sz="800" b="0">
+                <a:solidFill>
+                  <a:srgbClr val="2C3E50"/>
+                </a:solidFill>
+              </a:rPr>
+              <a:t/>
+            </a:r>
+          </a:p>
+        </p:txBody>
+      </p:sp>
+      <p:sp>
+        <p:nvSpPr>
+          <p:cNvPr id="17" name="TextBox 16"/>
+          <p:cNvSpPr txBox="1"/>
+          <p:nvPr/>
+        </p:nvSpPr>
+        <p:spPr>
+          <a:xfrm>
+            <a:off x="7863840" y="2628898"/>
+            <a:ext cx="4023360" cy="347472"/>
+          </a:xfrm>
+          <a:prstGeom prst="rect">
+            <a:avLst/>
+          </a:prstGeom>
+          <a:noFill/>
+        </p:spPr>
+        <p:txBody>
+          <a:bodyPr wrap="square">
+            <a:spAutoFit/>
+          </a:bodyPr>
+          <a:lstStyle/>
+          <a:p>
+            <a:pPr algn="l"/>
+            <a:r>
+              <a:rPr sz="1400" b="1">
+                <a:solidFill>
+                  <a:srgbClr val="2C3E50"/>
+                </a:solidFill>
+              </a:rPr>
+              <a:t>Cycle 2 (weight_load=0):</a:t>
+            </a:r>
+          </a:p>
+        </p:txBody>
+      </p:sp>
+      <p:sp>
+        <p:nvSpPr>
+          <p:cNvPr id="18" name="TextBox 17"/>
+          <p:cNvSpPr txBox="1"/>
+          <p:nvPr/>
+        </p:nvSpPr>
+        <p:spPr>
+          <a:xfrm>
+            <a:off x="7863840" y="2948938"/>
+            <a:ext cx="4023360" cy="347472"/>
+          </a:xfrm>
+          <a:prstGeom prst="rect">
+            <a:avLst/>
+          </a:prstGeom>
+          <a:noFill/>
+        </p:spPr>
+        <p:txBody>
+          <a:bodyPr wrap="square">
+            <a:spAutoFit/>
+          </a:bodyPr>
+          <a:lstStyle/>
+          <a:p>
+            <a:pPr algn="l"/>
+            <a:r>
+              <a:rPr sz="1300" b="0">
+                <a:solidFill>
+                  <a:srgbClr val="8E44AD"/>
+                </a:solidFill>
+              </a:rPr>
+              <a:t>wreg stays</a:t>
+            </a:r>
+          </a:p>
+        </p:txBody>
+      </p:sp>
+      <p:sp>
+        <p:nvSpPr>
+          <p:cNvPr id="19" name="TextBox 18"/>
+          <p:cNvSpPr txBox="1"/>
+          <p:nvPr/>
+        </p:nvSpPr>
+        <p:spPr>
+          <a:xfrm>
+            <a:off x="7863840" y="3246118"/>
+            <a:ext cx="4023360" cy="347472"/>
+          </a:xfrm>
+          <a:prstGeom prst="rect">
+            <a:avLst/>
+          </a:prstGeom>
+          <a:noFill/>
+        </p:spPr>
+        <p:txBody>
+          <a:bodyPr wrap="square">
+            <a:spAutoFit/>
+          </a:bodyPr>
+          <a:lstStyle/>
+          <a:p>
+            <a:pPr algn="l"/>
+            <a:r>
+              <a:rPr sz="1300" b="0">
+                <a:solidFill>
+                  <a:srgbClr val="27AE60"/>
+                </a:solidFill>
+              </a:rPr>
+              <a:t>out ← MAC(new wreg) ✓</a:t>
+            </a:r>
+          </a:p>
+        </p:txBody>
+      </p:sp>
+    </p:spTree>
+  </p:cSld>
+  <p:clrMapOvr>
+    <a:masterClrMapping/>
+  </p:clrMapOvr>
+</p:sld>
+</file>
+
+<file path=ppt/slides/slide5.xml><?xml version="1.0" encoding="utf-8"?>
+<p:sld xmlns:a="http://schemas.openxmlformats.org/drawingml/2006/main" xmlns:p="http://schemas.openxmlformats.org/presentationml/2006/main" xmlns:r="http://schemas.openxmlformats.org/officeDocument/2006/relationships">
+  <p:cSld>
+    <p:bg>
+      <p:bgPr>
+        <a:solidFill>
+          <a:srgbClr val="F2F4F6"/>
+        </a:solidFill>
+        <a:effectLst/>
+      </p:bgPr>
+    </p:bg>
+    <p:spTree>
+      <p:nvGrpSpPr>
+        <p:cNvPr id="1" name=""/>
+        <p:cNvGrpSpPr/>
+        <p:nvPr/>
+      </p:nvGrpSpPr>
+      <p:grpSpPr/>
+      <p:sp>
+        <p:nvSpPr>
+          <p:cNvPr id="2" name="Rectangle 1"/>
+          <p:cNvSpPr/>
+          <p:nvPr/>
+        </p:nvSpPr>
+        <p:spPr>
+          <a:xfrm>
+            <a:off x="0" y="0"/>
+            <a:ext cx="12188952" cy="82296"/>
+          </a:xfrm>
+          <a:prstGeom prst="rect">
+            <a:avLst/>
+          </a:prstGeom>
+          <a:solidFill>
+            <a:srgbClr val="008B8B"/>
+          </a:solidFill>
+          <a:ln>
+            <a:noFill/>
+          </a:ln>
+        </p:spPr>
+        <p:style>
+          <a:lnRef idx="1">
+            <a:schemeClr val="accent1"/>
+          </a:lnRef>
+          <a:fillRef idx="3">
+            <a:schemeClr val="accent1"/>
+          </a:fillRef>
+          <a:effectRef idx="2">
+            <a:schemeClr val="accent1"/>
+          </a:effectRef>
+          <a:fontRef idx="minor">
+            <a:schemeClr val="lt1"/>
+          </a:fontRef>
+        </p:style>
+        <p:txBody>
+          <a:bodyPr rtlCol="0" anchor="ctr"/>
+          <a:lstStyle/>
+          <a:p>
+            <a:pPr algn="ctr"/>
+          </a:p>
+        </p:txBody>
+      </p:sp>
+      <p:sp>
+        <p:nvSpPr>
+          <p:cNvPr id="3" name="TextBox 2"/>
+          <p:cNvSpPr txBox="1"/>
+          <p:nvPr/>
+        </p:nvSpPr>
+        <p:spPr>
+          <a:xfrm>
+            <a:off x="457200" y="137160"/>
+            <a:ext cx="8229600" cy="548640"/>
+          </a:xfrm>
+          <a:prstGeom prst="rect">
+            <a:avLst/>
+          </a:prstGeom>
+          <a:noFill/>
+        </p:spPr>
+        <p:txBody>
+          <a:bodyPr wrap="square">
+            <a:spAutoFit/>
+          </a:bodyPr>
+          <a:lstStyle/>
+          <a:p>
+            <a:pPr algn="l"/>
+            <a:r>
+              <a:rPr sz="3000" b="1">
+                <a:solidFill>
+                  <a:srgbClr val="2C3E50"/>
+                </a:solidFill>
+              </a:rPr>
+              <a:t>Simulation Results</a:t>
+            </a:r>
+          </a:p>
+        </p:txBody>
+      </p:sp>
+      <p:pic>
+        <p:nvPicPr>
+          <p:cNvPr id="4" name="Picture 3" descr="slide_results.png"/>
+          <p:cNvPicPr>
+            <a:picLocks noChangeAspect="1"/>
+          </p:cNvPicPr>
+          <p:nvPr/>
+        </p:nvPicPr>
+        <p:blipFill>
+          <a:blip r:embed="rId2"/>
+          <a:stretch>
+            <a:fillRect/>
+          </a:stretch>
+        </p:blipFill>
+        <p:spPr>
+          <a:xfrm>
+            <a:off x="274320" y="777240"/>
+            <a:ext cx="6583680" cy="5303520"/>
+          </a:xfrm>
+          <a:prstGeom prst="rect">
+            <a:avLst/>
+          </a:prstGeom>
+        </p:spPr>
+      </p:pic>
+      <p:sp>
+        <p:nvSpPr>
+          <p:cNvPr id="5" name="Rectangle 4"/>
+          <p:cNvSpPr/>
+          <p:nvPr/>
+        </p:nvSpPr>
+        <p:spPr>
+          <a:xfrm>
+            <a:off x="6949440" y="868680"/>
+            <a:ext cx="5029200" cy="1097280"/>
+          </a:xfrm>
+          <a:prstGeom prst="rect">
+            <a:avLst/>
+          </a:prstGeom>
+          <a:solidFill>
+            <a:srgbClr val="FFFFFF"/>
+          </a:solidFill>
+          <a:ln w="25400">
+            <a:solidFill>
+              <a:srgbClr val="27AE60"/>
+            </a:solidFill>
+          </a:ln>
+        </p:spPr>
+        <p:style>
+          <a:lnRef idx="1">
+            <a:schemeClr val="accent1"/>
+          </a:lnRef>
+          <a:fillRef idx="3">
+            <a:schemeClr val="accent1"/>
+          </a:fillRef>
+          <a:effectRef idx="2">
+            <a:schemeClr val="accent1"/>
+          </a:effectRef>
+          <a:fontRef idx="minor">
+            <a:schemeClr val="lt1"/>
+          </a:fontRef>
+        </p:style>
+        <p:txBody>
+          <a:bodyPr rtlCol="0" anchor="ctr"/>
+          <a:lstStyle/>
+          <a:p>
+            <a:pPr algn="ctr"/>
+          </a:p>
+        </p:txBody>
+      </p:sp>
+      <p:sp>
+        <p:nvSpPr>
+          <p:cNvPr id="6" name="TextBox 5"/>
+          <p:cNvSpPr txBox="1"/>
+          <p:nvPr/>
+        </p:nvSpPr>
+        <p:spPr>
+          <a:xfrm>
+            <a:off x="7086600" y="941832"/>
+            <a:ext cx="3200400" cy="457200"/>
+          </a:xfrm>
+          <a:prstGeom prst="rect">
+            <a:avLst/>
+          </a:prstGeom>
+          <a:noFill/>
+        </p:spPr>
+        <p:txBody>
+          <a:bodyPr wrap="square">
+            <a:spAutoFit/>
+          </a:bodyPr>
+          <a:lstStyle/>
+          <a:p>
+            <a:pPr algn="l"/>
+            <a:r>
+              <a:rPr sz="2200" b="1">
+                <a:solidFill>
+                  <a:srgbClr val="2C3E50"/>
+                </a:solidFill>
+              </a:rPr>
+              <a:t>out0 = −40</a:t>
+            </a:r>
+          </a:p>
+        </p:txBody>
+      </p:sp>
+      <p:sp>
+        <p:nvSpPr>
+          <p:cNvPr id="7" name="TextBox 6"/>
+          <p:cNvSpPr txBox="1"/>
+          <p:nvPr/>
+        </p:nvSpPr>
+        <p:spPr>
+          <a:xfrm>
+            <a:off x="7086600" y="1399032"/>
+            <a:ext cx="3200400" cy="411480"/>
+          </a:xfrm>
+          <a:prstGeom prst="rect">
+            <a:avLst/>
+          </a:prstGeom>
+          <a:noFill/>
+        </p:spPr>
+        <p:txBody>
+          <a:bodyPr wrap="square">
+            <a:spAutoFit/>
+          </a:bodyPr>
+          <a:lstStyle/>
+          <a:p>
+            <a:pPr algn="l"/>
+            <a:r>
+              <a:rPr sz="1300" b="0">
+                <a:solidFill>
+                  <a:srgbClr val="7F8C8D"/>
+                </a:solidFill>
+              </a:rPr>
+              <a:t>+10+20−30−40</a:t>
+            </a:r>
+          </a:p>
+        </p:txBody>
+      </p:sp>
+      <p:sp>
+        <p:nvSpPr>
+          <p:cNvPr id="8" name="TextBox 7"/>
+          <p:cNvSpPr txBox="1"/>
+          <p:nvPr/>
+        </p:nvSpPr>
+        <p:spPr>
+          <a:xfrm>
+            <a:off x="9601200" y="941832"/>
+            <a:ext cx="2194560" cy="457200"/>
+          </a:xfrm>
+          <a:prstGeom prst="rect">
+            <a:avLst/>
+          </a:prstGeom>
+          <a:noFill/>
+        </p:spPr>
+        <p:txBody>
+          <a:bodyPr wrap="square">
+            <a:spAutoFit/>
+          </a:bodyPr>
+          <a:lstStyle/>
+          <a:p>
+            <a:pPr algn="r"/>
+            <a:r>
+              <a:rPr sz="2000" b="1">
+                <a:solidFill>
+                  <a:srgbClr val="27AE60"/>
+                </a:solidFill>
+              </a:rPr>
+              <a:t>✓ PASS</a:t>
+            </a:r>
+          </a:p>
+        </p:txBody>
+      </p:sp>
+      <p:sp>
+        <p:nvSpPr>
+          <p:cNvPr id="9" name="Rectangle 8"/>
+          <p:cNvSpPr/>
+          <p:nvPr/>
+        </p:nvSpPr>
+        <p:spPr>
+          <a:xfrm>
+            <a:off x="6949440" y="2167128"/>
+            <a:ext cx="5029200" cy="1097280"/>
+          </a:xfrm>
+          <a:prstGeom prst="rect">
+            <a:avLst/>
+          </a:prstGeom>
+          <a:solidFill>
+            <a:srgbClr val="FFFFFF"/>
+          </a:solidFill>
+          <a:ln w="25400">
+            <a:solidFill>
+              <a:srgbClr val="27AE60"/>
+            </a:solidFill>
+          </a:ln>
+        </p:spPr>
+        <p:style>
+          <a:lnRef idx="1">
+            <a:schemeClr val="accent1"/>
+          </a:lnRef>
+          <a:fillRef idx="3">
+            <a:schemeClr val="accent1"/>
+          </a:fillRef>
+          <a:effectRef idx="2">
+            <a:schemeClr val="accent1"/>
+          </a:effectRef>
+          <a:fontRef idx="minor">
+            <a:schemeClr val="lt1"/>
+          </a:fontRef>
+        </p:style>
+        <p:txBody>
+          <a:bodyPr rtlCol="0" anchor="ctr"/>
+          <a:lstStyle/>
+          <a:p>
+            <a:pPr algn="ctr"/>
+          </a:p>
+        </p:txBody>
+      </p:sp>
+      <p:sp>
+        <p:nvSpPr>
+          <p:cNvPr id="10" name="TextBox 9"/>
+          <p:cNvSpPr txBox="1"/>
+          <p:nvPr/>
+        </p:nvSpPr>
+        <p:spPr>
+          <a:xfrm>
+            <a:off x="7086600" y="2240280"/>
+            <a:ext cx="3200400" cy="457200"/>
+          </a:xfrm>
+          <a:prstGeom prst="rect">
+            <a:avLst/>
+          </a:prstGeom>
+          <a:noFill/>
+        </p:spPr>
+        <p:txBody>
+          <a:bodyPr wrap="square">
+            <a:spAutoFit/>
+          </a:bodyPr>
+          <a:lstStyle/>
+          <a:p>
+            <a:pPr algn="l"/>
+            <a:r>
+              <a:rPr sz="2200" b="1">
+                <a:solidFill>
+                  <a:srgbClr val="2C3E50"/>
+                </a:solidFill>
+              </a:rPr>
+              <a:t>out1 =   0</a:t>
+            </a:r>
+          </a:p>
+        </p:txBody>
+      </p:sp>
+      <p:sp>
+        <p:nvSpPr>
+          <p:cNvPr id="11" name="TextBox 10"/>
+          <p:cNvSpPr txBox="1"/>
+          <p:nvPr/>
+        </p:nvSpPr>
+        <p:spPr>
+          <a:xfrm>
+            <a:off x="7086600" y="2697480"/>
+            <a:ext cx="3200400" cy="411480"/>
+          </a:xfrm>
+          <a:prstGeom prst="rect">
+            <a:avLst/>
+          </a:prstGeom>
+          <a:noFill/>
+        </p:spPr>
+        <p:txBody>
+          <a:bodyPr wrap="square">
+            <a:spAutoFit/>
+          </a:bodyPr>
+          <a:lstStyle/>
+          <a:p>
+            <a:pPr algn="l"/>
+            <a:r>
+              <a:rPr sz="1300" b="0">
+                <a:solidFill>
+                  <a:srgbClr val="7F8C8D"/>
+                </a:solidFill>
+              </a:rPr>
+              <a:t>−10+20+30−40</a:t>
+            </a:r>
+          </a:p>
+        </p:txBody>
+      </p:sp>
+      <p:sp>
+        <p:nvSpPr>
+          <p:cNvPr id="12" name="TextBox 11"/>
+          <p:cNvSpPr txBox="1"/>
+          <p:nvPr/>
+        </p:nvSpPr>
+        <p:spPr>
+          <a:xfrm>
+            <a:off x="9601200" y="2240280"/>
+            <a:ext cx="2194560" cy="457200"/>
+          </a:xfrm>
+          <a:prstGeom prst="rect">
+            <a:avLst/>
+          </a:prstGeom>
+          <a:noFill/>
+        </p:spPr>
+        <p:txBody>
+          <a:bodyPr wrap="square">
+            <a:spAutoFit/>
+          </a:bodyPr>
+          <a:lstStyle/>
+          <a:p>
+            <a:pPr algn="r"/>
+            <a:r>
+              <a:rPr sz="2000" b="1">
+                <a:solidFill>
+                  <a:srgbClr val="27AE60"/>
+                </a:solidFill>
+              </a:rPr>
+              <a:t>✓ PASS</a:t>
+            </a:r>
+          </a:p>
+        </p:txBody>
+      </p:sp>
+      <p:sp>
+        <p:nvSpPr>
+          <p:cNvPr id="13" name="Rectangle 12"/>
+          <p:cNvSpPr/>
+          <p:nvPr/>
+        </p:nvSpPr>
+        <p:spPr>
+          <a:xfrm>
+            <a:off x="6949440" y="3465576"/>
+            <a:ext cx="5029200" cy="1097280"/>
+          </a:xfrm>
+          <a:prstGeom prst="rect">
+            <a:avLst/>
+          </a:prstGeom>
+          <a:solidFill>
+            <a:srgbClr val="FFFFFF"/>
+          </a:solidFill>
+          <a:ln w="25400">
+            <a:solidFill>
+              <a:srgbClr val="27AE60"/>
+            </a:solidFill>
+          </a:ln>
+        </p:spPr>
+        <p:style>
+          <a:lnRef idx="1">
+            <a:schemeClr val="accent1"/>
+          </a:lnRef>
+          <a:fillRef idx="3">
+            <a:schemeClr val="accent1"/>
+          </a:fillRef>
+          <a:effectRef idx="2">
+            <a:schemeClr val="accent1"/>
+          </a:effectRef>
+          <a:fontRef idx="minor">
+            <a:schemeClr val="lt1"/>
+          </a:fontRef>
+        </p:style>
+        <p:txBody>
+          <a:bodyPr rtlCol="0" anchor="ctr"/>
+          <a:lstStyle/>
+          <a:p>
+            <a:pPr algn="ctr"/>
+          </a:p>
+        </p:txBody>
+      </p:sp>
+      <p:sp>
+        <p:nvSpPr>
+          <p:cNvPr id="14" name="TextBox 13"/>
+          <p:cNvSpPr txBox="1"/>
+          <p:nvPr/>
+        </p:nvSpPr>
+        <p:spPr>
+          <a:xfrm>
+            <a:off x="7086600" y="3538728"/>
+            <a:ext cx="3200400" cy="457200"/>
+          </a:xfrm>
+          <a:prstGeom prst="rect">
+            <a:avLst/>
+          </a:prstGeom>
+          <a:noFill/>
+        </p:spPr>
+        <p:txBody>
+          <a:bodyPr wrap="square">
+            <a:spAutoFit/>
+          </a:bodyPr>
+          <a:lstStyle/>
+          <a:p>
+            <a:pPr algn="l"/>
+            <a:r>
+              <a:rPr sz="2200" b="1">
+                <a:solidFill>
+                  <a:srgbClr val="2C3E50"/>
+                </a:solidFill>
+              </a:rPr>
+              <a:t>out2 = −20</a:t>
+            </a:r>
+          </a:p>
+        </p:txBody>
+      </p:sp>
+      <p:sp>
+        <p:nvSpPr>
+          <p:cNvPr id="15" name="TextBox 14"/>
+          <p:cNvSpPr txBox="1"/>
+          <p:nvPr/>
+        </p:nvSpPr>
+        <p:spPr>
+          <a:xfrm>
+            <a:off x="7086600" y="3995928"/>
+            <a:ext cx="3200400" cy="411480"/>
+          </a:xfrm>
+          <a:prstGeom prst="rect">
+            <a:avLst/>
+          </a:prstGeom>
+          <a:noFill/>
+        </p:spPr>
+        <p:txBody>
+          <a:bodyPr wrap="square">
+            <a:spAutoFit/>
+          </a:bodyPr>
+          <a:lstStyle/>
+          <a:p>
+            <a:pPr algn="l"/>
+            <a:r>
+              <a:rPr sz="1300" b="0">
+                <a:solidFill>
+                  <a:srgbClr val="7F8C8D"/>
+                </a:solidFill>
+              </a:rPr>
+              <a:t>+10−20+30−40</a:t>
+            </a:r>
+          </a:p>
+        </p:txBody>
+      </p:sp>
+      <p:sp>
+        <p:nvSpPr>
+          <p:cNvPr id="16" name="TextBox 15"/>
+          <p:cNvSpPr txBox="1"/>
+          <p:nvPr/>
+        </p:nvSpPr>
+        <p:spPr>
+          <a:xfrm>
+            <a:off x="9601200" y="3538728"/>
+            <a:ext cx="2194560" cy="457200"/>
+          </a:xfrm>
+          <a:prstGeom prst="rect">
+            <a:avLst/>
+          </a:prstGeom>
+          <a:noFill/>
+        </p:spPr>
+        <p:txBody>
+          <a:bodyPr wrap="square">
+            <a:spAutoFit/>
+          </a:bodyPr>
+          <a:lstStyle/>
+          <a:p>
+            <a:pPr algn="r"/>
+            <a:r>
+              <a:rPr sz="2000" b="1">
+                <a:solidFill>
+                  <a:srgbClr val="27AE60"/>
+                </a:solidFill>
+              </a:rPr>
+              <a:t>✓ PASS</a:t>
+            </a:r>
+          </a:p>
+        </p:txBody>
+      </p:sp>
+      <p:sp>
+        <p:nvSpPr>
+          <p:cNvPr id="17" name="Rectangle 16"/>
+          <p:cNvSpPr/>
+          <p:nvPr/>
+        </p:nvSpPr>
+        <p:spPr>
+          <a:xfrm>
+            <a:off x="6949440" y="4764024"/>
+            <a:ext cx="5029200" cy="1097280"/>
+          </a:xfrm>
+          <a:prstGeom prst="rect">
+            <a:avLst/>
+          </a:prstGeom>
+          <a:solidFill>
+            <a:srgbClr val="FFFFFF"/>
+          </a:solidFill>
+          <a:ln w="25400">
+            <a:solidFill>
+              <a:srgbClr val="27AE60"/>
+            </a:solidFill>
+          </a:ln>
+        </p:spPr>
+        <p:style>
+          <a:lnRef idx="1">
+            <a:schemeClr val="accent1"/>
+          </a:lnRef>
+          <a:fillRef idx="3">
+            <a:schemeClr val="accent1"/>
+          </a:fillRef>
+          <a:effectRef idx="2">
+            <a:schemeClr val="accent1"/>
+          </a:effectRef>
+          <a:fontRef idx="minor">
+            <a:schemeClr val="lt1"/>
+          </a:fontRef>
+        </p:style>
+        <p:txBody>
+          <a:bodyPr rtlCol="0" anchor="ctr"/>
+          <a:lstStyle/>
+          <a:p>
+            <a:pPr algn="ctr"/>
+          </a:p>
+        </p:txBody>
+      </p:sp>
+      <p:sp>
+        <p:nvSpPr>
+          <p:cNvPr id="18" name="TextBox 17"/>
+          <p:cNvSpPr txBox="1"/>
+          <p:nvPr/>
+        </p:nvSpPr>
+        <p:spPr>
+          <a:xfrm>
+            <a:off x="7086600" y="4837176"/>
+            <a:ext cx="3200400" cy="457200"/>
+          </a:xfrm>
+          <a:prstGeom prst="rect">
+            <a:avLst/>
+          </a:prstGeom>
+          <a:noFill/>
+        </p:spPr>
+        <p:txBody>
+          <a:bodyPr wrap="square">
+            <a:spAutoFit/>
+          </a:bodyPr>
+          <a:lstStyle/>
+          <a:p>
+            <a:pPr algn="l"/>
+            <a:r>
+              <a:rPr sz="2200" b="1">
+                <a:solidFill>
+                  <a:srgbClr val="2C3E50"/>
+                </a:solidFill>
+              </a:rPr>
+              <a:t>out3 = −20</a:t>
+            </a:r>
+          </a:p>
+        </p:txBody>
+      </p:sp>
+      <p:sp>
+        <p:nvSpPr>
+          <p:cNvPr id="19" name="TextBox 18"/>
+          <p:cNvSpPr txBox="1"/>
+          <p:nvPr/>
+        </p:nvSpPr>
+        <p:spPr>
+          <a:xfrm>
+            <a:off x="7086600" y="5294376"/>
+            <a:ext cx="3200400" cy="411480"/>
+          </a:xfrm>
+          <a:prstGeom prst="rect">
+            <a:avLst/>
+          </a:prstGeom>
+          <a:noFill/>
+        </p:spPr>
+        <p:txBody>
+          <a:bodyPr wrap="square">
+            <a:spAutoFit/>
+          </a:bodyPr>
+          <a:lstStyle/>
+          <a:p>
+            <a:pPr algn="l"/>
+            <a:r>
+              <a:rPr sz="1300" b="0">
+                <a:solidFill>
+                  <a:srgbClr val="7F8C8D"/>
+                </a:solidFill>
+              </a:rPr>
+              <a:t>−10−20−30+40</a:t>
+            </a:r>
+          </a:p>
+        </p:txBody>
+      </p:sp>
+      <p:sp>
+        <p:nvSpPr>
+          <p:cNvPr id="20" name="TextBox 19"/>
+          <p:cNvSpPr txBox="1"/>
+          <p:nvPr/>
+        </p:nvSpPr>
+        <p:spPr>
+          <a:xfrm>
+            <a:off x="9601200" y="4837176"/>
+            <a:ext cx="2194560" cy="457200"/>
+          </a:xfrm>
+          <a:prstGeom prst="rect">
+            <a:avLst/>
+          </a:prstGeom>
+          <a:noFill/>
+        </p:spPr>
+        <p:txBody>
+          <a:bodyPr wrap="square">
+            <a:spAutoFit/>
+          </a:bodyPr>
+          <a:lstStyle/>
+          <a:p>
+            <a:pPr algn="r"/>
+            <a:r>
+              <a:rPr sz="2000" b="1">
+                <a:solidFill>
+                  <a:srgbClr val="27AE60"/>
+                </a:solidFill>
+              </a:rPr>
+              <a:t>✓ PASS</a:t>
+            </a:r>
+          </a:p>
+        </p:txBody>
+      </p:sp>
+      <p:sp>
+        <p:nvSpPr>
+          <p:cNvPr id="21" name="Rectangle 20"/>
+          <p:cNvSpPr/>
+          <p:nvPr/>
+        </p:nvSpPr>
+        <p:spPr>
+          <a:xfrm>
+            <a:off x="6949440" y="5943600"/>
+            <a:ext cx="5029200" cy="685800"/>
+          </a:xfrm>
+          <a:prstGeom prst="rect">
+            <a:avLst/>
+          </a:prstGeom>
+          <a:solidFill>
+            <a:srgbClr val="8E44AD"/>
+          </a:solidFill>
+          <a:ln>
+            <a:noFill/>
+          </a:ln>
+        </p:spPr>
+        <p:style>
+          <a:lnRef idx="1">
+            <a:schemeClr val="accent1"/>
+          </a:lnRef>
+          <a:fillRef idx="3">
+            <a:schemeClr val="accent1"/>
+          </a:fillRef>
+          <a:effectRef idx="2">
+            <a:schemeClr val="accent1"/>
+          </a:effectRef>
+          <a:fontRef idx="minor">
+            <a:schemeClr val="lt1"/>
+          </a:fontRef>
+        </p:style>
+        <p:txBody>
+          <a:bodyPr rtlCol="0" anchor="ctr"/>
+          <a:lstStyle/>
+          <a:p>
+            <a:pPr algn="ctr"/>
+          </a:p>
+        </p:txBody>
+      </p:sp>
+      <p:sp>
+        <p:nvSpPr>
+          <p:cNvPr id="22" name="TextBox 21"/>
+          <p:cNvSpPr txBox="1"/>
+          <p:nvPr/>
+        </p:nvSpPr>
+        <p:spPr>
+          <a:xfrm>
+            <a:off x="6949440" y="5989320"/>
+            <a:ext cx="5029200" cy="594360"/>
+          </a:xfrm>
+          <a:prstGeom prst="rect">
+            <a:avLst/>
+          </a:prstGeom>
+          <a:noFill/>
+        </p:spPr>
+        <p:txBody>
+          <a:bodyPr wrap="square">
+            <a:spAutoFit/>
+          </a:bodyPr>
+          <a:lstStyle/>
+          <a:p>
+            <a:pPr algn="ctr"/>
+            <a:r>
+              <a:rPr sz="2600" b="1">
+                <a:solidFill>
+                  <a:srgbClr val="FFFFFF"/>
+                </a:solidFill>
+              </a:rPr>
+              <a:t>4 / 4 PASS</a:t>
+            </a:r>
+          </a:p>
+        </p:txBody>
+      </p:sp>
     </p:spTree>
   </p:cSld>
   <p:clrMapOvr>

</xml_diff>